<commit_message>
chore: consolidate rendering and exemplar release hardening
</commit_message>
<xml_diff>
--- a/projects/templates/template_pitch_deck/output/pptx/template_template_pitch_medium.pptx
+++ b/projects/templates/template_pitch_deck/output/pptx/template_template_pitch_medium.pptx
@@ -42,6 +42,7 @@
     <p:sldId id="290" r:id="rId42"/>
     <p:sldId id="291" r:id="rId43"/>
     <p:sldId id="292" r:id="rId44"/>
+    <p:sldId id="293" r:id="rId45"/>
   </p:sldIdLst>
   <p:sldSz cx="9144000" cy="5143500" type="screen4x3"/>
   <p:notesSz cx="6858000" cy="9144000"/>
@@ -3893,7 +3894,9 @@
           </a:fontRef>
         </p:style>
         <p:txBody>
-          <a:bodyPr rtlCol="0" anchor="ctr" lIns="502920"/>
+          <a:bodyPr rtlCol="0" anchor="ctr" wrap="none" lIns="502920" rIns="502920">
+            <a:noAutofit/>
+          </a:bodyPr>
           <a:lstStyle/>
           <a:p>
             <a:pPr algn="ctr"/>
@@ -3902,6 +3905,7 @@
                 <a:solidFill>
                   <a:srgbClr val="FFFFFF"/>
                 </a:solidFill>
+                <a:latin typeface="Helvetica"/>
               </a:rPr>
               <a:t>Visualization</a:t>
             </a:r>
@@ -3916,8 +3920,8 @@
         </p:nvSpPr>
         <p:spPr>
           <a:xfrm>
-            <a:off x="502920" y="1097280"/>
-            <a:ext cx="8138160" cy="1856232"/>
+            <a:off x="502920" y="1070305"/>
+            <a:ext cx="8138160" cy="1383410"/>
           </a:xfrm>
           <a:prstGeom prst="rect">
             <a:avLst/>
@@ -3925,38 +3929,58 @@
           <a:noFill/>
         </p:spPr>
         <p:txBody>
-          <a:bodyPr wrap="square">
-            <a:spAutoFit/>
+          <a:bodyPr wrap="none" anchor="t" lIns="0" rIns="0" tIns="0" bIns="0">
+            <a:noAutofit/>
           </a:bodyPr>
           <a:lstStyle/>
           <a:p>
             <a:pPr>
+              <a:lnSpc>
+                <a:spcPts val="2100"/>
+              </a:lnSpc>
               <a:spcAft>
-                <a:spcPts val="1000"/>
+                <a:spcPts val="828"/>
               </a:spcAft>
               <a:defRPr sz="1800">
                 <a:solidFill>
                   <a:srgbClr val="0A0A0A"/>
                 </a:solidFill>
+                <a:latin typeface="Helvetica"/>
               </a:defRPr>
             </a:pPr>
             <a:r>
-              <a:t>•  Four figures — architecture overview, pipeline stages, module inventory, comparative feature matrix — are generated from the same live data, not hand-drawn.</a:t>
+              <a:t>• Four figures — architecture overview, pipeline stages, module inventory,</a:t>
+            </a:r>
+            <a:br/>
+            <a:r>
+              <a:t>comparative feature matrix — are generated from the same live data, not</a:t>
+            </a:r>
+            <a:br/>
+            <a:r>
+              <a:t>hand-drawn.</a:t>
             </a:r>
           </a:p>
           <a:p>
             <a:pPr>
+              <a:lnSpc>
+                <a:spcPts val="2100"/>
+              </a:lnSpc>
               <a:spcAft>
-                <a:spcPts val="1000"/>
+                <a:spcPts val="0"/>
               </a:spcAft>
               <a:defRPr sz="1800">
                 <a:solidFill>
                   <a:srgbClr val="0A0A0A"/>
                 </a:solidFill>
+                <a:latin typeface="Helvetica"/>
               </a:defRPr>
             </a:pPr>
             <a:r>
-              <a:t>•  generate_architecture_viz.py orchestrates dedicated figure modules sharing one palette module, so the visual language stays consistent across all four.</a:t>
+              <a:t>• generate_architecture_viz.py orchestrates dedicated figure modules sharing</a:t>
+            </a:r>
+            <a:br/>
+            <a:r>
+              <a:t>one palette module, so the visual language stays consistent across all four.</a:t>
             </a:r>
           </a:p>
         </p:txBody>
@@ -4086,7 +4110,9 @@
           </a:fontRef>
         </p:style>
         <p:txBody>
-          <a:bodyPr rtlCol="0" anchor="ctr" lIns="502920"/>
+          <a:bodyPr rtlCol="0" anchor="ctr" wrap="none" lIns="502920" rIns="502920">
+            <a:noAutofit/>
+          </a:bodyPr>
           <a:lstStyle/>
           <a:p>
             <a:pPr algn="ctr"/>
@@ -4095,6 +4121,7 @@
                 <a:solidFill>
                   <a:srgbClr val="FFFFFF"/>
                 </a:solidFill>
+                <a:latin typeface="Helvetica"/>
               </a:rPr>
               <a:t>Two-layer architecture, at a glance</a:t>
             </a:r>
@@ -4117,8 +4144,8 @@
         </p:blipFill>
         <p:spPr>
           <a:xfrm>
-            <a:off x="914400" y="914400"/>
-            <a:ext cx="7315200" cy="8366175"/>
+            <a:off x="3078875" y="914400"/>
+            <a:ext cx="2986249" cy="3415284"/>
           </a:xfrm>
           <a:prstGeom prst="rect">
             <a:avLst/>
@@ -4284,7 +4311,9 @@
           </a:fontRef>
         </p:style>
         <p:txBody>
-          <a:bodyPr rtlCol="0" anchor="ctr" lIns="502920"/>
+          <a:bodyPr rtlCol="0" anchor="ctr" wrap="none" lIns="502920" rIns="502920">
+            <a:noAutofit/>
+          </a:bodyPr>
           <a:lstStyle/>
           <a:p>
             <a:pPr algn="ctr"/>
@@ -4293,6 +4322,7 @@
                 <a:solidFill>
                   <a:srgbClr val="FFFFFF"/>
                 </a:solidFill>
+                <a:latin typeface="Helvetica"/>
               </a:rPr>
               <a:t>The core pipeline, stage by stage</a:t>
             </a:r>
@@ -4315,8 +4345,8 @@
         </p:blipFill>
         <p:spPr>
           <a:xfrm>
-            <a:off x="914400" y="914400"/>
-            <a:ext cx="7315200" cy="2063993"/>
+            <a:off x="502920" y="1473946"/>
+            <a:ext cx="8138159" cy="2296191"/>
           </a:xfrm>
           <a:prstGeom prst="rect">
             <a:avLst/>
@@ -4453,7 +4483,7 @@
         </p:nvSpPr>
         <p:spPr>
           <a:xfrm>
-            <a:off x="502920" y="2514600"/>
+            <a:off x="502920" y="2559050"/>
             <a:ext cx="8138160" cy="38100"/>
           </a:xfrm>
           <a:prstGeom prst="rect">
@@ -4497,8 +4527,8 @@
         </p:nvSpPr>
         <p:spPr>
           <a:xfrm>
-            <a:off x="502920" y="2103120"/>
-            <a:ext cx="8138160" cy="914400"/>
+            <a:off x="502920" y="1918970"/>
+            <a:ext cx="8138160" cy="502920"/>
           </a:xfrm>
           <a:prstGeom prst="rect">
             <a:avLst/>
@@ -4506,16 +4536,22 @@
           <a:noFill/>
         </p:spPr>
         <p:txBody>
-          <a:bodyPr wrap="square">
-            <a:spAutoFit/>
+          <a:bodyPr wrap="none" anchor="t" lIns="0" rIns="0" tIns="0" bIns="0">
+            <a:noAutofit/>
           </a:bodyPr>
           <a:lstStyle/>
           <a:p>
+            <a:pPr>
+              <a:lnSpc>
+                <a:spcPts val="3300"/>
+              </a:lnSpc>
+            </a:pPr>
             <a:r>
               <a:rPr sz="3300" b="1">
                 <a:solidFill>
                   <a:srgbClr val="0A0A0A"/>
                 </a:solidFill>
+                <a:latin typeface="Helvetica"/>
               </a:rPr>
               <a:t>Proof, not adjectives</a:t>
             </a:r>
@@ -4868,7 +4904,9 @@
           </a:fontRef>
         </p:style>
         <p:txBody>
-          <a:bodyPr rtlCol="0" anchor="ctr" lIns="502920"/>
+          <a:bodyPr rtlCol="0" anchor="ctr" wrap="none" lIns="502920" rIns="502920">
+            <a:noAutofit/>
+          </a:bodyPr>
           <a:lstStyle/>
           <a:p>
             <a:pPr algn="ctr"/>
@@ -4877,6 +4915,7 @@
                 <a:solidFill>
                   <a:srgbClr val="FFFFFF"/>
                 </a:solidFill>
+                <a:latin typeface="Helvetica"/>
               </a:rPr>
               <a:t>No partial credit</a:t>
             </a:r>
@@ -4891,8 +4930,8 @@
         </p:nvSpPr>
         <p:spPr>
           <a:xfrm>
-            <a:off x="502920" y="1097280"/>
-            <a:ext cx="8138160" cy="1344168"/>
+            <a:off x="502920" y="1070305"/>
+            <a:ext cx="8138160" cy="1116711"/>
           </a:xfrm>
           <a:prstGeom prst="rect">
             <a:avLst/>
@@ -4900,38 +4939,54 @@
           <a:noFill/>
         </p:spPr>
         <p:txBody>
-          <a:bodyPr wrap="square">
-            <a:spAutoFit/>
+          <a:bodyPr wrap="none" anchor="t" lIns="0" rIns="0" tIns="0" bIns="0">
+            <a:noAutofit/>
           </a:bodyPr>
           <a:lstStyle/>
           <a:p>
             <a:pPr>
+              <a:lnSpc>
+                <a:spcPts val="2100"/>
+              </a:lnSpc>
               <a:spcAft>
-                <a:spcPts val="1000"/>
+                <a:spcPts val="828"/>
               </a:spcAft>
               <a:defRPr sz="1800">
                 <a:solidFill>
                   <a:srgbClr val="0A0A0A"/>
                 </a:solidFill>
+                <a:latin typeface="Helvetica"/>
               </a:defRPr>
             </a:pPr>
             <a:r>
-              <a:t>•  90% project-coverage floor and a no-mocks testing policy apply to this project exactly as they do to the 24 other exemplars.</a:t>
+              <a:t>• 90% project-coverage floor and a no-mocks testing policy apply to this project</a:t>
+            </a:r>
+            <a:br/>
+            <a:r>
+              <a:t>exactly as they do to the 24 other exemplars.</a:t>
             </a:r>
           </a:p>
           <a:p>
             <a:pPr>
+              <a:lnSpc>
+                <a:spcPts val="2100"/>
+              </a:lnSpc>
               <a:spcAft>
-                <a:spcPts val="1000"/>
+                <a:spcPts val="0"/>
               </a:spcAft>
               <a:defRPr sz="1800">
                 <a:solidFill>
                   <a:srgbClr val="0A0A0A"/>
                 </a:solidFill>
+                <a:latin typeface="Helvetica"/>
               </a:defRPr>
             </a:pPr>
             <a:r>
-              <a:t>•  Every pipeline run either passes its own gate or fails loudly — there is no partial-credit reporting path.</a:t>
+              <a:t>• Every pipeline run either passes its own gate or fails loudly — there is no</a:t>
+            </a:r>
+            <a:br/>
+            <a:r>
+              <a:t>partial-credit reporting path.</a:t>
             </a:r>
           </a:p>
         </p:txBody>
@@ -5095,7 +5150,9 @@
           </a:fontRef>
         </p:style>
         <p:txBody>
-          <a:bodyPr rtlCol="0" anchor="ctr" lIns="502920"/>
+          <a:bodyPr rtlCol="0" anchor="ctr" wrap="none" lIns="502920" rIns="502920">
+            <a:noAutofit/>
+          </a:bodyPr>
           <a:lstStyle/>
           <a:p>
             <a:pPr algn="ctr"/>
@@ -5104,6 +5161,7 @@
                 <a:solidFill>
                   <a:srgbClr val="FFFFFF"/>
                 </a:solidFill>
+                <a:latin typeface="Helvetica"/>
               </a:rPr>
               <a:t>Already public</a:t>
             </a:r>
@@ -5118,8 +5176,8 @@
         </p:nvSpPr>
         <p:spPr>
           <a:xfrm>
-            <a:off x="502920" y="1097280"/>
-            <a:ext cx="8138160" cy="2368296"/>
+            <a:off x="502920" y="1070305"/>
+            <a:ext cx="8138160" cy="1755267"/>
           </a:xfrm>
           <a:prstGeom prst="rect">
             <a:avLst/>
@@ -5127,53 +5185,77 @@
           <a:noFill/>
         </p:spPr>
         <p:txBody>
-          <a:bodyPr wrap="square">
-            <a:spAutoFit/>
+          <a:bodyPr wrap="none" anchor="t" lIns="0" rIns="0" tIns="0" bIns="0">
+            <a:noAutofit/>
           </a:bodyPr>
           <a:lstStyle/>
           <a:p>
             <a:pPr>
+              <a:lnSpc>
+                <a:spcPts val="2100"/>
+              </a:lnSpc>
               <a:spcAft>
-                <a:spcPts val="1000"/>
+                <a:spcPts val="828"/>
               </a:spcAft>
               <a:defRPr sz="1800">
                 <a:solidFill>
                   <a:srgbClr val="0A0A0A"/>
                 </a:solidFill>
+                <a:latin typeface="Helvetica"/>
               </a:defRPr>
             </a:pPr>
             <a:r>
-              <a:t>•  Concept DOI 10.5281/zenodo.20419007, with a version-specific Zenodo deposit for the current release.</a:t>
+              <a:t>• Concept DOI 10.5281/zenodo.20419007, with a version-specific Zenodo</a:t>
+            </a:r>
+            <a:br/>
+            <a:r>
+              <a:t>deposit for the current release.</a:t>
             </a:r>
           </a:p>
           <a:p>
             <a:pPr>
+              <a:lnSpc>
+                <a:spcPts val="2100"/>
+              </a:lnSpc>
               <a:spcAft>
-                <a:spcPts val="1000"/>
+                <a:spcPts val="828"/>
               </a:spcAft>
               <a:defRPr sz="1800">
                 <a:solidFill>
                   <a:srgbClr val="0A0A0A"/>
                 </a:solidFill>
+                <a:latin typeface="Helvetica"/>
               </a:defRPr>
             </a:pPr>
             <a:r>
-              <a:t>•  9 durable publication records on file: Zenodo, GitHub, PyPI (sandbox), IPFS, Software Heritage, GitHub Pages, Netlify, Hugging Face, OSF.</a:t>
+              <a:t>• 9 durable publication records on file: Zenodo, GitHub, PyPI (sandbox), IPFS,</a:t>
+            </a:r>
+            <a:br/>
+            <a:r>
+              <a:t>Software Heritage, GitHub Pages, Netlify, Hugging Face, OSF.</a:t>
             </a:r>
           </a:p>
           <a:p>
             <a:pPr>
+              <a:lnSpc>
+                <a:spcPts val="2100"/>
+              </a:lnSpc>
               <a:spcAft>
-                <a:spcPts val="1000"/>
+                <a:spcPts val="0"/>
               </a:spcAft>
               <a:defRPr sz="1800">
                 <a:solidFill>
                   <a:srgbClr val="0A0A0A"/>
                 </a:solidFill>
+                <a:latin typeface="Helvetica"/>
               </a:defRPr>
             </a:pPr>
             <a:r>
-              <a:t>•  Licensed Apache-2.0 — the introspection code, not only the prose, is available for a science-integrity team to audit directly at docxology/template_template.</a:t>
+              <a:t>• Licensed Apache-2.0 — the introspection code, not only the prose, is available</a:t>
+            </a:r>
+            <a:br/>
+            <a:r>
+              <a:t>for a science-integrity team to audit directly at docxology/template_template.</a:t>
             </a:r>
           </a:p>
         </p:txBody>
@@ -5308,7 +5390,7 @@
         </p:nvSpPr>
         <p:spPr>
           <a:xfrm>
-            <a:off x="502920" y="2514600"/>
+            <a:off x="502920" y="2559050"/>
             <a:ext cx="8138160" cy="38100"/>
           </a:xfrm>
           <a:prstGeom prst="rect">
@@ -5352,8 +5434,8 @@
         </p:nvSpPr>
         <p:spPr>
           <a:xfrm>
-            <a:off x="502920" y="2103120"/>
-            <a:ext cx="8138160" cy="914400"/>
+            <a:off x="502920" y="1918970"/>
+            <a:ext cx="8138160" cy="502920"/>
           </a:xfrm>
           <a:prstGeom prst="rect">
             <a:avLst/>
@@ -5361,16 +5443,22 @@
           <a:noFill/>
         </p:spPr>
         <p:txBody>
-          <a:bodyPr wrap="square">
-            <a:spAutoFit/>
+          <a:bodyPr wrap="none" anchor="t" lIns="0" rIns="0" tIns="0" bIns="0">
+            <a:noAutofit/>
           </a:bodyPr>
           <a:lstStyle/>
           <a:p>
+            <a:pPr>
+              <a:lnSpc>
+                <a:spcPts val="3300"/>
+              </a:lnSpc>
+            </a:pPr>
             <a:r>
               <a:rPr sz="3300" b="1">
                 <a:solidFill>
                   <a:srgbClr val="0A0A0A"/>
                 </a:solidFill>
+                <a:latin typeface="Helvetica"/>
               </a:rPr>
               <a:t>The pattern generalizes</a:t>
             </a:r>
@@ -5502,15 +5590,18 @@
           </a:fontRef>
         </p:style>
         <p:txBody>
-          <a:bodyPr rtlCol="0" anchor="ctr" lIns="502920"/>
+          <a:bodyPr rtlCol="0" anchor="ctr" wrap="none" lIns="502920" rIns="502920">
+            <a:noAutofit/>
+          </a:bodyPr>
           <a:lstStyle/>
           <a:p>
             <a:pPr algn="ctr"/>
             <a:r>
-              <a:rPr sz="2300" b="1">
+              <a:rPr sz="2400" b="1">
                 <a:solidFill>
                   <a:srgbClr val="FFFFFF"/>
                 </a:solidFill>
+                <a:latin typeface="Helvetica"/>
               </a:rPr>
               <a:t>The full roster, not one cherry-picked example</a:t>
             </a:r>
@@ -5525,8 +5616,8 @@
         </p:nvSpPr>
         <p:spPr>
           <a:xfrm>
-            <a:off x="502920" y="1097280"/>
-            <a:ext cx="8138160" cy="2560320"/>
+            <a:off x="502920" y="1070305"/>
+            <a:ext cx="8138160" cy="2611754"/>
           </a:xfrm>
           <a:prstGeom prst="rect">
             <a:avLst/>
@@ -5534,53 +5625,63 @@
           <a:noFill/>
         </p:spPr>
         <p:txBody>
-          <a:bodyPr wrap="square">
-            <a:spAutoFit/>
+          <a:bodyPr wrap="none" anchor="t" lIns="0" rIns="0" tIns="0" bIns="0">
+            <a:noAutofit/>
           </a:bodyPr>
           <a:lstStyle/>
           <a:p>
             <a:pPr>
+              <a:lnSpc>
+                <a:spcPts val="2100"/>
+              </a:lnSpc>
               <a:spcAft>
-                <a:spcPts val="1000"/>
+                <a:spcPts val="0"/>
               </a:spcAft>
               <a:defRPr sz="1800">
                 <a:solidFill>
                   <a:srgbClr val="0A0A0A"/>
                 </a:solidFill>
+                <a:latin typeface="Helvetica"/>
               </a:defRPr>
             </a:pPr>
             <a:r>
-              <a:t>•  projects/templates/ holds all 24 public exemplars: template_active_inference, template_advanced_literature_review, template_autopoiesis, template_autoresearch_project, template_autoscientists, template_code_project, template_data_descriptor, template_eda_notebook, template_formal, template_gold_refinement, template_literature_meta_analysis, template_madlib, template_methods_paper, template_newspaper, template_pitch_deck, template_pools_rules_tools, template_prose_project, template_redacted_report, template_registered_report, template_search_project, template_sia, template_storybook, template_template, template_textbook.</a:t>
-            </a:r>
-          </a:p>
-          <a:p>
-            <a:pPr>
-              <a:spcAft>
-                <a:spcPts val="1000"/>
-              </a:spcAft>
-              <a:defRPr sz="1800">
-                <a:solidFill>
-                  <a:srgbClr val="0A0A0A"/>
-                </a:solidFill>
-              </a:defRPr>
-            </a:pPr>
-            <a:r>
-              <a:t>•  template_active_inference is called out here only as one concrete instance to point to — every name in that list is an independently-built exemplar following the identical two-layer architecture, not a hand-picked best case.</a:t>
-            </a:r>
-          </a:p>
-          <a:p>
-            <a:pPr>
-              <a:spcAft>
-                <a:spcPts val="1000"/>
-              </a:spcAft>
-              <a:defRPr sz="1800">
-                <a:solidFill>
-                  <a:srgbClr val="0A0A0A"/>
-                </a:solidFill>
-              </a:defRPr>
-            </a:pPr>
-            <a:r>
-              <a:t>•  Neither exemplar's coverage gate or drift check required any special-casing to add — the contract is uniform across all 24 projects, and the folder itself is the evidence, not a claim about it.</a:t>
+              <a:t>• projects/templates/ holds all 24 public exemplars: template_active_inference,</a:t>
+            </a:r>
+            <a:br/>
+            <a:r>
+              <a:t>template_advanced_literature_review, template_autopoiesis,</a:t>
+            </a:r>
+            <a:br/>
+            <a:r>
+              <a:t>template_autoresearch_project, template_autoscientists,</a:t>
+            </a:r>
+            <a:br/>
+            <a:r>
+              <a:t>template_code_project, template_data_descriptor, template_eda_notebook,</a:t>
+            </a:r>
+            <a:br/>
+            <a:r>
+              <a:t>template_formal, template_gold_refinement, template_literature_meta_analysis,</a:t>
+            </a:r>
+            <a:br/>
+            <a:r>
+              <a:t>template_madlib, template_methods_paper, template_newspaper,</a:t>
+            </a:r>
+            <a:br/>
+            <a:r>
+              <a:t>template_pitch_deck, template_pools_rules_tools, template_prose_project,</a:t>
+            </a:r>
+            <a:br/>
+            <a:r>
+              <a:t>template_redacted_report, template_registered_report,</a:t>
+            </a:r>
+            <a:br/>
+            <a:r>
+              <a:t>template_search_project, template_sia, template_storybook, template_template,</a:t>
+            </a:r>
+            <a:br/>
+            <a:r>
+              <a:t>template_textbook.</a:t>
             </a:r>
           </a:p>
         </p:txBody>
@@ -5744,7 +5845,9 @@
           </a:fontRef>
         </p:style>
         <p:txBody>
-          <a:bodyPr rtlCol="0" anchor="ctr" lIns="502920"/>
+          <a:bodyPr rtlCol="0" anchor="ctr" wrap="none" lIns="502920" rIns="502920">
+            <a:noAutofit/>
+          </a:bodyPr>
           <a:lstStyle/>
           <a:p>
             <a:pPr algn="ctr"/>
@@ -5753,8 +5856,9 @@
                 <a:solidFill>
                   <a:srgbClr val="FFFFFF"/>
                 </a:solidFill>
+                <a:latin typeface="Helvetica"/>
               </a:rPr>
-              <a:t>Two-layer architecture</a:t>
+              <a:t>One contract across all public exemplars</a:t>
             </a:r>
           </a:p>
         </p:txBody>
@@ -5767,8 +5871,8 @@
         </p:nvSpPr>
         <p:spPr>
           <a:xfrm>
-            <a:off x="502920" y="1097280"/>
-            <a:ext cx="8138160" cy="2112264"/>
+            <a:off x="502920" y="1070305"/>
+            <a:ext cx="8138160" cy="1650110"/>
           </a:xfrm>
           <a:prstGeom prst="rect">
             <a:avLst/>
@@ -5776,61 +5880,104 @@
           <a:noFill/>
         </p:spPr>
         <p:txBody>
-          <a:bodyPr wrap="square">
+          <a:bodyPr wrap="none" anchor="t" lIns="0" rIns="0" tIns="0" bIns="0">
+            <a:noAutofit/>
+          </a:bodyPr>
+          <a:lstStyle/>
+          <a:p>
+            <a:pPr>
+              <a:lnSpc>
+                <a:spcPts val="2100"/>
+              </a:lnSpc>
+              <a:spcAft>
+                <a:spcPts val="828"/>
+              </a:spcAft>
+              <a:defRPr sz="1800">
+                <a:solidFill>
+                  <a:srgbClr val="0A0A0A"/>
+                </a:solidFill>
+                <a:latin typeface="Helvetica"/>
+              </a:defRPr>
+            </a:pPr>
+            <a:r>
+              <a:t>• template_active_inference is called out here only as one concrete instance to</a:t>
+            </a:r>
+            <a:br/>
+            <a:r>
+              <a:t>point to — every name in that list is an independently-built exemplar following</a:t>
+            </a:r>
+            <a:br/>
+            <a:r>
+              <a:t>the identical two-layer architecture, not a hand-picked best case.</a:t>
+            </a:r>
+          </a:p>
+          <a:p>
+            <a:pPr>
+              <a:lnSpc>
+                <a:spcPts val="2100"/>
+              </a:lnSpc>
+              <a:spcAft>
+                <a:spcPts val="0"/>
+              </a:spcAft>
+              <a:defRPr sz="1800">
+                <a:solidFill>
+                  <a:srgbClr val="0A0A0A"/>
+                </a:solidFill>
+                <a:latin typeface="Helvetica"/>
+              </a:defRPr>
+            </a:pPr>
+            <a:r>
+              <a:t>• Neither exemplar's coverage gate or drift check required any special-casing to</a:t>
+            </a:r>
+            <a:br/>
+            <a:r>
+              <a:t>add — the contract is uniform across all 24 projects, and the folder itself is the</a:t>
+            </a:r>
+            <a:br/>
+            <a:r>
+              <a:t>evidence, not a claim about it.</a:t>
+            </a:r>
+          </a:p>
+        </p:txBody>
+      </p:sp>
+      <p:sp>
+        <p:nvSpPr>
+          <p:cNvPr id="5" name="TextBox 4"/>
+          <p:cNvSpPr txBox="1"/>
+          <p:nvPr/>
+        </p:nvSpPr>
+        <p:spPr>
+          <a:xfrm>
+            <a:off x="502920" y="4823460"/>
+            <a:ext cx="5486400" cy="274320"/>
+          </a:xfrm>
+          <a:prstGeom prst="rect">
+            <a:avLst/>
+          </a:prstGeom>
+          <a:noFill/>
+        </p:spPr>
+        <p:txBody>
+          <a:bodyPr wrap="none">
             <a:spAutoFit/>
           </a:bodyPr>
           <a:lstStyle/>
           <a:p>
-            <a:pPr>
-              <a:spcAft>
-                <a:spcPts val="1000"/>
-              </a:spcAft>
-              <a:defRPr sz="1800">
-                <a:solidFill>
-                  <a:srgbClr val="0A0A0A"/>
-                </a:solidFill>
-              </a:defRPr>
-            </a:pPr>
-            <a:r>
-              <a:t>•  Layer 1 (infrastructure/): generic, reusable — rendering, validation, publishing, provenance, testing utilities.</a:t>
-            </a:r>
-          </a:p>
-          <a:p>
-            <a:pPr>
-              <a:spcAft>
-                <a:spcPts val="1000"/>
-              </a:spcAft>
-              <a:defRPr sz="1800">
-                <a:solidFill>
-                  <a:srgbClr val="0A0A0A"/>
-                </a:solidFill>
-              </a:defRPr>
-            </a:pPr>
-            <a:r>
-              <a:t>•  Layer 2 (projects/{name}/src/): domain-specific — each exemplar's own algorithms, kept out of infrastructure/ by convention and enforced by drift checks.</a:t>
-            </a:r>
-          </a:p>
-          <a:p>
-            <a:pPr>
-              <a:spcAft>
-                <a:spcPts val="1000"/>
-              </a:spcAft>
-              <a:defRPr sz="1800">
-                <a:solidFill>
-                  <a:srgbClr val="0A0A0A"/>
-                </a:solidFill>
-              </a:defRPr>
-            </a:pPr>
-            <a:r>
-              <a:t>•  Thin orchestrator scripts (projects/{name}/scripts/) coordinate the two layers but implement no business logic themselves.</a:t>
+            <a:r>
+              <a:rPr sz="900" i="1">
+                <a:solidFill>
+                  <a:srgbClr val="8A8F99"/>
+                </a:solidFill>
+                <a:hlinkClick r:id="rId2"/>
+              </a:rPr>
+              <a:t>Source: docs/_generated/active_projects.md</a:t>
             </a:r>
           </a:p>
         </p:txBody>
       </p:sp>
       <p:pic>
         <p:nvPicPr>
-          <p:cNvPr id="5" name="Picture 4" descr="image.png">
-            <a:hlinkClick r:id="rId3"/>
+          <p:cNvPr id="6" name="Picture 5" descr="image.png">
+            <a:hlinkClick r:id="rId4"/>
           </p:cNvPr>
           <p:cNvPicPr>
             <a:picLocks noChangeAspect="1"/>
@@ -5838,7 +5985,7 @@
           <p:nvPr/>
         </p:nvPicPr>
         <p:blipFill>
-          <a:blip r:embed="rId2"/>
+          <a:blip r:embed="rId3"/>
           <a:stretch>
             <a:fillRect/>
           </a:stretch>
@@ -5952,7 +6099,9 @@
           </a:fontRef>
         </p:style>
         <p:txBody>
-          <a:bodyPr rtlCol="0" anchor="ctr" lIns="502920"/>
+          <a:bodyPr rtlCol="0" anchor="ctr" wrap="none" lIns="502920" rIns="502920">
+            <a:noAutofit/>
+          </a:bodyPr>
           <a:lstStyle/>
           <a:p>
             <a:pPr algn="ctr"/>
@@ -5961,6 +6110,7 @@
                 <a:solidFill>
                   <a:srgbClr val="FFFFFF"/>
                 </a:solidFill>
+                <a:latin typeface="Helvetica"/>
               </a:rPr>
               <a:t>The problem</a:t>
             </a:r>
@@ -5975,8 +6125,8 @@
         </p:nvSpPr>
         <p:spPr>
           <a:xfrm>
-            <a:off x="502920" y="1097280"/>
-            <a:ext cx="8138160" cy="2112264"/>
+            <a:off x="502920" y="1070305"/>
+            <a:ext cx="8138160" cy="1755267"/>
           </a:xfrm>
           <a:prstGeom prst="rect">
             <a:avLst/>
@@ -5984,53 +6134,77 @@
           <a:noFill/>
         </p:spPr>
         <p:txBody>
-          <a:bodyPr wrap="square">
-            <a:spAutoFit/>
+          <a:bodyPr wrap="none" anchor="t" lIns="0" rIns="0" tIns="0" bIns="0">
+            <a:noAutofit/>
           </a:bodyPr>
           <a:lstStyle/>
           <a:p>
             <a:pPr>
+              <a:lnSpc>
+                <a:spcPts val="2100"/>
+              </a:lnSpc>
               <a:spcAft>
-                <a:spcPts val="1000"/>
+                <a:spcPts val="828"/>
               </a:spcAft>
               <a:defRPr sz="1800">
                 <a:solidFill>
                   <a:srgbClr val="0A0A0A"/>
                 </a:solidFill>
+                <a:latin typeface="Helvetica"/>
               </a:defRPr>
             </a:pPr>
             <a:r>
-              <a:t>•  Research groups publish claims about their own tools and pipelines that no one outside the team can re-check.</a:t>
+              <a:t>• Research groups publish claims about their own tools and pipelines that no</a:t>
+            </a:r>
+            <a:br/>
+            <a:r>
+              <a:t>one outside the team can re-check.</a:t>
             </a:r>
           </a:p>
           <a:p>
             <a:pPr>
+              <a:lnSpc>
+                <a:spcPts val="2100"/>
+              </a:lnSpc>
               <a:spcAft>
-                <a:spcPts val="1000"/>
+                <a:spcPts val="828"/>
               </a:spcAft>
               <a:defRPr sz="1800">
                 <a:solidFill>
                   <a:srgbClr val="0A0A0A"/>
                 </a:solidFill>
+                <a:latin typeface="Helvetica"/>
               </a:defRPr>
             </a:pPr>
             <a:r>
-              <a:t>•  Manuscripts describing infrastructure go stale the moment the infrastructure changes underneath them.</a:t>
+              <a:t>• Manuscripts describing infrastructure go stale the moment the infrastructure</a:t>
+            </a:r>
+            <a:br/>
+            <a:r>
+              <a:t>changes underneath them.</a:t>
             </a:r>
           </a:p>
           <a:p>
             <a:pPr>
+              <a:lnSpc>
+                <a:spcPts val="2100"/>
+              </a:lnSpc>
               <a:spcAft>
-                <a:spcPts val="1000"/>
+                <a:spcPts val="0"/>
               </a:spcAft>
               <a:defRPr sz="1800">
                 <a:solidFill>
                   <a:srgbClr val="0A0A0A"/>
                 </a:solidFill>
+                <a:latin typeface="Helvetica"/>
               </a:defRPr>
             </a:pPr>
             <a:r>
-              <a:t>•  Reproducibility efforts usually stop at the data and code layer — the documentation layer is still hand-maintained and drifts silently.</a:t>
+              <a:t>• Reproducibility efforts usually stop at the data and code layer — the</a:t>
+            </a:r>
+            <a:br/>
+            <a:r>
+              <a:t>documentation layer is still hand-maintained and drifts silently.</a:t>
             </a:r>
           </a:p>
         </p:txBody>
@@ -6160,7 +6334,9 @@
           </a:fontRef>
         </p:style>
         <p:txBody>
-          <a:bodyPr rtlCol="0" anchor="ctr" lIns="502920"/>
+          <a:bodyPr rtlCol="0" anchor="ctr" wrap="none" lIns="502920" rIns="502920">
+            <a:noAutofit/>
+          </a:bodyPr>
           <a:lstStyle/>
           <a:p>
             <a:pPr algn="ctr"/>
@@ -6169,8 +6345,9 @@
                 <a:solidFill>
                   <a:srgbClr val="FFFFFF"/>
                 </a:solidFill>
+                <a:latin typeface="Helvetica"/>
               </a:rPr>
-              <a:t>Governance and confidentiality</a:t>
+              <a:t>Two-layer architecture</a:t>
             </a:r>
           </a:p>
         </p:txBody>
@@ -6183,8 +6360,8 @@
         </p:nvSpPr>
         <p:spPr>
           <a:xfrm>
-            <a:off x="502920" y="1097280"/>
-            <a:ext cx="8138160" cy="1600200"/>
+            <a:off x="502920" y="1070305"/>
+            <a:ext cx="8138160" cy="2021967"/>
           </a:xfrm>
           <a:prstGeom prst="rect">
             <a:avLst/>
@@ -6192,38 +6369,81 @@
           <a:noFill/>
         </p:spPr>
         <p:txBody>
-          <a:bodyPr wrap="square">
-            <a:spAutoFit/>
+          <a:bodyPr wrap="none" anchor="t" lIns="0" rIns="0" tIns="0" bIns="0">
+            <a:noAutofit/>
           </a:bodyPr>
           <a:lstStyle/>
           <a:p>
             <a:pPr>
+              <a:lnSpc>
+                <a:spcPts val="2100"/>
+              </a:lnSpc>
               <a:spcAft>
-                <a:spcPts val="1000"/>
+                <a:spcPts val="828"/>
               </a:spcAft>
               <a:defRPr sz="1800">
                 <a:solidFill>
                   <a:srgbClr val="0A0A0A"/>
                 </a:solidFill>
+                <a:latin typeface="Helvetica"/>
               </a:defRPr>
             </a:pPr>
             <a:r>
-              <a:t>•  Only projects/templates/ is public and CI-gated; private working projects render locally through the same pipeline without ever being tracked.</a:t>
+              <a:t>• Layer 1 (infrastructure/): generic, reusable — rendering, validation, publishing,</a:t>
+            </a:r>
+            <a:br/>
+            <a:r>
+              <a:t>provenance, testing utilities.</a:t>
             </a:r>
           </a:p>
           <a:p>
             <a:pPr>
+              <a:lnSpc>
+                <a:spcPts val="2100"/>
+              </a:lnSpc>
               <a:spcAft>
-                <a:spcPts val="1000"/>
+                <a:spcPts val="828"/>
               </a:spcAft>
               <a:defRPr sz="1800">
                 <a:solidFill>
                   <a:srgbClr val="0A0A0A"/>
                 </a:solidFill>
+                <a:latin typeface="Helvetica"/>
               </a:defRPr>
             </a:pPr>
             <a:r>
-              <a:t>•  A dedicated audit (scripts/audit/check_tracked_all.py) fails CI if any private project path is accidentally committed.</a:t>
+              <a:t>• Layer 2 (projects/{name}/src/): domain-specific — each exemplar's own</a:t>
+            </a:r>
+            <a:br/>
+            <a:r>
+              <a:t>algorithms, kept out of infrastructure/ by convention and enforced by drift</a:t>
+            </a:r>
+            <a:br/>
+            <a:r>
+              <a:t>checks.</a:t>
+            </a:r>
+          </a:p>
+          <a:p>
+            <a:pPr>
+              <a:lnSpc>
+                <a:spcPts val="2100"/>
+              </a:lnSpc>
+              <a:spcAft>
+                <a:spcPts val="0"/>
+              </a:spcAft>
+              <a:defRPr sz="1800">
+                <a:solidFill>
+                  <a:srgbClr val="0A0A0A"/>
+                </a:solidFill>
+                <a:latin typeface="Helvetica"/>
+              </a:defRPr>
+            </a:pPr>
+            <a:r>
+              <a:t>• Thin orchestrator scripts (projects/{name}/scripts/) coordinate the two layers</a:t>
+            </a:r>
+            <a:br/>
+            <a:r>
+              <a:t>but implement no business logic themselves.</a:t>
             </a:r>
           </a:p>
         </p:txBody>
@@ -6324,14 +6544,14 @@
         </p:nvSpPr>
         <p:spPr>
           <a:xfrm>
-            <a:off x="502920" y="2514600"/>
-            <a:ext cx="8138160" cy="38100"/>
+            <a:off x="0" y="0"/>
+            <a:ext cx="9144000" cy="822960"/>
           </a:xfrm>
           <a:prstGeom prst="rect">
             <a:avLst/>
           </a:prstGeom>
           <a:solidFill>
-            <a:srgbClr val="B3131A"/>
+            <a:srgbClr val="0A0A0A"/>
           </a:solidFill>
           <a:ln>
             <a:noFill/>
@@ -6353,10 +6573,21 @@
           </a:fontRef>
         </p:style>
         <p:txBody>
-          <a:bodyPr rtlCol="0" anchor="ctr"/>
+          <a:bodyPr rtlCol="0" anchor="ctr" wrap="none" lIns="502920" rIns="502920">
+            <a:noAutofit/>
+          </a:bodyPr>
           <a:lstStyle/>
           <a:p>
             <a:pPr algn="ctr"/>
+            <a:r>
+              <a:rPr sz="2400" b="1">
+                <a:solidFill>
+                  <a:srgbClr val="FFFFFF"/>
+                </a:solidFill>
+                <a:latin typeface="Helvetica"/>
+              </a:rPr>
+              <a:t>Governance and confidentiality</a:t>
+            </a:r>
           </a:p>
         </p:txBody>
       </p:sp>
@@ -6368,8 +6599,8 @@
         </p:nvSpPr>
         <p:spPr>
           <a:xfrm>
-            <a:off x="502920" y="2103120"/>
-            <a:ext cx="8138160" cy="914400"/>
+            <a:off x="502920" y="1070305"/>
+            <a:ext cx="8138160" cy="1116711"/>
           </a:xfrm>
           <a:prstGeom prst="rect">
             <a:avLst/>
@@ -6377,18 +6608,54 @@
           <a:noFill/>
         </p:spPr>
         <p:txBody>
-          <a:bodyPr wrap="square">
-            <a:spAutoFit/>
+          <a:bodyPr wrap="none" anchor="t" lIns="0" rIns="0" tIns="0" bIns="0">
+            <a:noAutofit/>
           </a:bodyPr>
           <a:lstStyle/>
           <a:p>
-            <a:r>
-              <a:rPr sz="2900" b="1">
+            <a:pPr>
+              <a:lnSpc>
+                <a:spcPts val="2100"/>
+              </a:lnSpc>
+              <a:spcAft>
+                <a:spcPts val="828"/>
+              </a:spcAft>
+              <a:defRPr sz="1800">
                 <a:solidFill>
                   <a:srgbClr val="0A0A0A"/>
                 </a:solidFill>
-              </a:rPr>
-              <a:t>Scientific integrity, by construction</a:t>
+                <a:latin typeface="Helvetica"/>
+              </a:defRPr>
+            </a:pPr>
+            <a:r>
+              <a:t>• Only projects/templates/ is public and CI-gated; private working projects render</a:t>
+            </a:r>
+            <a:br/>
+            <a:r>
+              <a:t>locally through the same pipeline without ever being tracked.</a:t>
+            </a:r>
+          </a:p>
+          <a:p>
+            <a:pPr>
+              <a:lnSpc>
+                <a:spcPts val="2100"/>
+              </a:lnSpc>
+              <a:spcAft>
+                <a:spcPts val="0"/>
+              </a:spcAft>
+              <a:defRPr sz="1800">
+                <a:solidFill>
+                  <a:srgbClr val="0A0A0A"/>
+                </a:solidFill>
+                <a:latin typeface="Helvetica"/>
+              </a:defRPr>
+            </a:pPr>
+            <a:r>
+              <a:t>• A dedicated audit (scripts/audit/check_tracked_all.py) fails CI if any private</a:t>
+            </a:r>
+            <a:br/>
+            <a:r>
+              <a:t>project path is accidentally committed.</a:t>
             </a:r>
           </a:p>
         </p:txBody>
@@ -6489,14 +6756,14 @@
         </p:nvSpPr>
         <p:spPr>
           <a:xfrm>
-            <a:off x="0" y="0"/>
-            <a:ext cx="9144000" cy="822960"/>
+            <a:off x="502920" y="2559050"/>
+            <a:ext cx="8138160" cy="38100"/>
           </a:xfrm>
           <a:prstGeom prst="rect">
             <a:avLst/>
           </a:prstGeom>
           <a:solidFill>
-            <a:srgbClr val="0A0A0A"/>
+            <a:srgbClr val="B3131A"/>
           </a:solidFill>
           <a:ln>
             <a:noFill/>
@@ -6518,18 +6785,10 @@
           </a:fontRef>
         </p:style>
         <p:txBody>
-          <a:bodyPr rtlCol="0" anchor="ctr" lIns="502920"/>
+          <a:bodyPr rtlCol="0" anchor="ctr"/>
           <a:lstStyle/>
           <a:p>
             <a:pPr algn="ctr"/>
-            <a:r>
-              <a:rPr sz="2400" b="1">
-                <a:solidFill>
-                  <a:srgbClr val="FFFFFF"/>
-                </a:solidFill>
-              </a:rPr>
-              <a:t>Independent gates, not one</a:t>
-            </a:r>
           </a:p>
         </p:txBody>
       </p:sp>
@@ -6541,8 +6800,8 @@
         </p:nvSpPr>
         <p:spPr>
           <a:xfrm>
-            <a:off x="502920" y="1097280"/>
-            <a:ext cx="8138160" cy="2560320"/>
+            <a:off x="502920" y="1918970"/>
+            <a:ext cx="8138160" cy="502920"/>
           </a:xfrm>
           <a:prstGeom prst="rect">
             <a:avLst/>
@@ -6550,95 +6809,32 @@
           <a:noFill/>
         </p:spPr>
         <p:txBody>
-          <a:bodyPr wrap="square">
-            <a:spAutoFit/>
+          <a:bodyPr wrap="none" anchor="t" lIns="0" rIns="0" tIns="0" bIns="0">
+            <a:noAutofit/>
           </a:bodyPr>
           <a:lstStyle/>
           <a:p>
             <a:pPr>
-              <a:spcAft>
-                <a:spcPts val="1000"/>
-              </a:spcAft>
-              <a:defRPr sz="1800">
+              <a:lnSpc>
+                <a:spcPts val="3300"/>
+              </a:lnSpc>
+            </a:pPr>
+            <a:r>
+              <a:rPr sz="3300" b="1">
                 <a:solidFill>
                   <a:srgbClr val="0A0A0A"/>
                 </a:solidFill>
-              </a:defRPr>
-            </a:pPr>
-            <a:r>
-              <a:t>•  No-mocks testing policy, CI-enforced: scripts/audit/verify_no_mocks.py fails the build if any test imports MagicMock, mocker.patch, or unittest.mock — a checked gate, not a style preference.</a:t>
-            </a:r>
-          </a:p>
-          <a:p>
-            <a:pPr>
-              <a:spcAft>
-                <a:spcPts val="1000"/>
-              </a:spcAft>
-              <a:defRPr sz="1800">
-                <a:solidFill>
-                  <a:srgbClr val="0A0A0A"/>
-                </a:solidFill>
-              </a:defRPr>
-            </a:pPr>
-            <a:r>
-              <a:t>•  Coverage floors are enforced per project (90%) and for shared infrastructure (60%), not averaged away across the monorepo.</a:t>
-            </a:r>
-          </a:p>
-          <a:p>
-            <a:pPr>
-              <a:spcAft>
-                <a:spcPts val="1000"/>
-              </a:spcAft>
-              <a:defRPr sz="1800">
-                <a:solidFill>
-                  <a:srgbClr val="0A0A0A"/>
-                </a:solidFill>
-              </a:defRPr>
-            </a:pPr>
-            <a:r>
-              <a:t>•  A byte-level reproducibility invariant: two renders of identical content in the same environment produce an identical PDF — verified by a real, passing test, not assumed across every OS/toolchain combination.</a:t>
-            </a:r>
-          </a:p>
-        </p:txBody>
-      </p:sp>
-      <p:sp>
-        <p:nvSpPr>
-          <p:cNvPr id="5" name="TextBox 4"/>
-          <p:cNvSpPr txBox="1"/>
-          <p:nvPr/>
-        </p:nvSpPr>
-        <p:spPr>
-          <a:xfrm>
-            <a:off x="502920" y="4823460"/>
-            <a:ext cx="5486400" cy="274320"/>
-          </a:xfrm>
-          <a:prstGeom prst="rect">
-            <a:avLst/>
-          </a:prstGeom>
-          <a:noFill/>
-        </p:spPr>
-        <p:txBody>
-          <a:bodyPr wrap="none">
-            <a:spAutoFit/>
-          </a:bodyPr>
-          <a:lstStyle/>
-          <a:p>
-            <a:r>
-              <a:rPr sz="900" i="1">
-                <a:solidFill>
-                  <a:srgbClr val="8A8F99"/>
-                </a:solidFill>
-                <a:hlinkClick r:id="rId2"/>
+                <a:latin typeface="Helvetica"/>
               </a:rPr>
-              <a:t>Source: tests/infra_tests/rendering/test_slide_deck.py</a:t>
+              <a:t>Scientific integrity, by construction</a:t>
             </a:r>
           </a:p>
         </p:txBody>
       </p:sp>
       <p:pic>
         <p:nvPicPr>
-          <p:cNvPr id="6" name="Picture 5" descr="image.png">
-            <a:hlinkClick r:id="rId4"/>
+          <p:cNvPr id="5" name="Picture 4" descr="image.png">
+            <a:hlinkClick r:id="rId3"/>
           </p:cNvPr>
           <p:cNvPicPr>
             <a:picLocks noChangeAspect="1"/>
@@ -6646,7 +6842,7 @@
           <p:nvPr/>
         </p:nvPicPr>
         <p:blipFill>
-          <a:blip r:embed="rId3"/>
+          <a:blip r:embed="rId2"/>
           <a:stretch>
             <a:fillRect/>
           </a:stretch>
@@ -6732,7 +6928,7 @@
         <p:spPr>
           <a:xfrm>
             <a:off x="0" y="0"/>
-            <a:ext cx="9144000" cy="685800"/>
+            <a:ext cx="9144000" cy="822960"/>
           </a:xfrm>
           <a:prstGeom prst="rect">
             <a:avLst/>
@@ -6760,45 +6956,124 @@
           </a:fontRef>
         </p:style>
         <p:txBody>
-          <a:bodyPr rtlCol="0" anchor="ctr" lIns="502920"/>
+          <a:bodyPr rtlCol="0" anchor="ctr" wrap="none" lIns="502920" rIns="502920">
+            <a:noAutofit/>
+          </a:bodyPr>
           <a:lstStyle/>
           <a:p>
             <a:pPr algn="ctr"/>
             <a:r>
-              <a:rPr sz="2200" b="1">
+              <a:rPr sz="2400" b="1">
                 <a:solidFill>
                   <a:srgbClr val="FFFFFF"/>
                 </a:solidFill>
+                <a:latin typeface="Helvetica"/>
               </a:rPr>
-              <a:t>The integrity stack, gate by gate</a:t>
-            </a:r>
-          </a:p>
-        </p:txBody>
-      </p:sp>
-      <p:pic>
-        <p:nvPicPr>
-          <p:cNvPr id="4" name="Picture 3" descr="integrity_stack.png"/>
-          <p:cNvPicPr>
-            <a:picLocks noChangeAspect="1"/>
-          </p:cNvPicPr>
-          <p:nvPr/>
-        </p:nvPicPr>
-        <p:blipFill>
-          <a:blip r:embed="rId2"/>
-          <a:stretch>
-            <a:fillRect/>
-          </a:stretch>
-        </p:blipFill>
-        <p:spPr>
-          <a:xfrm>
-            <a:off x="914400" y="914400"/>
-            <a:ext cx="7315200" cy="4644571"/>
-          </a:xfrm>
-          <a:prstGeom prst="rect">
-            <a:avLst/>
-          </a:prstGeom>
-        </p:spPr>
-      </p:pic>
+              <a:t>Independent gates, not one</a:t>
+            </a:r>
+          </a:p>
+        </p:txBody>
+      </p:sp>
+      <p:sp>
+        <p:nvSpPr>
+          <p:cNvPr id="4" name="TextBox 3"/>
+          <p:cNvSpPr txBox="1"/>
+          <p:nvPr/>
+        </p:nvSpPr>
+        <p:spPr>
+          <a:xfrm>
+            <a:off x="502920" y="1070305"/>
+            <a:ext cx="8138160" cy="2288666"/>
+          </a:xfrm>
+          <a:prstGeom prst="rect">
+            <a:avLst/>
+          </a:prstGeom>
+          <a:noFill/>
+        </p:spPr>
+        <p:txBody>
+          <a:bodyPr wrap="none" anchor="t" lIns="0" rIns="0" tIns="0" bIns="0">
+            <a:noAutofit/>
+          </a:bodyPr>
+          <a:lstStyle/>
+          <a:p>
+            <a:pPr>
+              <a:lnSpc>
+                <a:spcPts val="2100"/>
+              </a:lnSpc>
+              <a:spcAft>
+                <a:spcPts val="828"/>
+              </a:spcAft>
+              <a:defRPr sz="1800">
+                <a:solidFill>
+                  <a:srgbClr val="0A0A0A"/>
+                </a:solidFill>
+                <a:latin typeface="Helvetica"/>
+              </a:defRPr>
+            </a:pPr>
+            <a:r>
+              <a:t>• No-mocks testing policy, CI-enforced: scripts/audit/verify_no_mocks.py fails</a:t>
+            </a:r>
+            <a:br/>
+            <a:r>
+              <a:t>the build if any test imports MagicMock, mocker.patch, or unittest.mock — a</a:t>
+            </a:r>
+            <a:br/>
+            <a:r>
+              <a:t>checked gate, not a style preference.</a:t>
+            </a:r>
+          </a:p>
+          <a:p>
+            <a:pPr>
+              <a:lnSpc>
+                <a:spcPts val="2100"/>
+              </a:lnSpc>
+              <a:spcAft>
+                <a:spcPts val="828"/>
+              </a:spcAft>
+              <a:defRPr sz="1800">
+                <a:solidFill>
+                  <a:srgbClr val="0A0A0A"/>
+                </a:solidFill>
+                <a:latin typeface="Helvetica"/>
+              </a:defRPr>
+            </a:pPr>
+            <a:r>
+              <a:t>• Coverage floors are enforced per project (90%) and for shared infrastructure</a:t>
+            </a:r>
+            <a:br/>
+            <a:r>
+              <a:t>(60%), not averaged away across the monorepo.</a:t>
+            </a:r>
+          </a:p>
+          <a:p>
+            <a:pPr>
+              <a:lnSpc>
+                <a:spcPts val="2100"/>
+              </a:lnSpc>
+              <a:spcAft>
+                <a:spcPts val="0"/>
+              </a:spcAft>
+              <a:defRPr sz="1800">
+                <a:solidFill>
+                  <a:srgbClr val="0A0A0A"/>
+                </a:solidFill>
+                <a:latin typeface="Helvetica"/>
+              </a:defRPr>
+            </a:pPr>
+            <a:r>
+              <a:t>• A byte-level reproducibility invariant: two renders of identical content in the</a:t>
+            </a:r>
+            <a:br/>
+            <a:r>
+              <a:t>same environment produce an identical PDF — verified by a real, passing test,</a:t>
+            </a:r>
+            <a:br/>
+            <a:r>
+              <a:t>not assumed across every OS/toolchain combination.</a:t>
+            </a:r>
+          </a:p>
+        </p:txBody>
+      </p:sp>
       <p:sp>
         <p:nvSpPr>
           <p:cNvPr id="5" name="TextBox 4"/>
@@ -6826,9 +7101,9 @@
                 <a:solidFill>
                   <a:srgbClr val="8A8F99"/>
                 </a:solidFill>
-                <a:hlinkClick r:id="rId3"/>
+                <a:hlinkClick r:id="rId2"/>
               </a:rPr>
-              <a:t>Source: projects/templates/template_pitch_deck/src/token_resolution.py</a:t>
+              <a:t>Source: tests/infra_tests/rendering/test_slide_deck.py</a:t>
             </a:r>
           </a:p>
         </p:txBody>
@@ -6836,7 +7111,7 @@
       <p:pic>
         <p:nvPicPr>
           <p:cNvPr id="6" name="Picture 5" descr="image.png">
-            <a:hlinkClick r:id="rId5"/>
+            <a:hlinkClick r:id="rId4"/>
           </p:cNvPr>
           <p:cNvPicPr>
             <a:picLocks noChangeAspect="1"/>
@@ -6844,7 +7119,7 @@
           <p:nvPr/>
         </p:nvPicPr>
         <p:blipFill>
-          <a:blip r:embed="rId4"/>
+          <a:blip r:embed="rId3"/>
           <a:stretch>
             <a:fillRect/>
           </a:stretch>
@@ -6930,7 +7205,7 @@
         <p:spPr>
           <a:xfrm>
             <a:off x="0" y="0"/>
-            <a:ext cx="9144000" cy="822960"/>
+            <a:ext cx="9144000" cy="685800"/>
           </a:xfrm>
           <a:prstGeom prst="rect">
             <a:avLst/>
@@ -6958,74 +7233,48 @@
           </a:fontRef>
         </p:style>
         <p:txBody>
-          <a:bodyPr rtlCol="0" anchor="ctr" lIns="502920"/>
+          <a:bodyPr rtlCol="0" anchor="ctr" wrap="none" lIns="502920" rIns="502920">
+            <a:noAutofit/>
+          </a:bodyPr>
           <a:lstStyle/>
           <a:p>
             <a:pPr algn="ctr"/>
             <a:r>
-              <a:rPr sz="2400" b="1">
+              <a:rPr sz="2200" b="1">
                 <a:solidFill>
                   <a:srgbClr val="FFFFFF"/>
                 </a:solidFill>
+                <a:latin typeface="Helvetica"/>
               </a:rPr>
-              <a:t>Coverage isn't a headline number</a:t>
-            </a:r>
-          </a:p>
-        </p:txBody>
-      </p:sp>
-      <p:sp>
-        <p:nvSpPr>
-          <p:cNvPr id="4" name="TextBox 3"/>
-          <p:cNvSpPr txBox="1"/>
-          <p:nvPr/>
-        </p:nvSpPr>
-        <p:spPr>
-          <a:xfrm>
-            <a:off x="502920" y="1097280"/>
-            <a:ext cx="8138160" cy="1600200"/>
-          </a:xfrm>
-          <a:prstGeom prst="rect">
-            <a:avLst/>
-          </a:prstGeom>
-          <a:noFill/>
-        </p:spPr>
-        <p:txBody>
-          <a:bodyPr wrap="square">
-            <a:spAutoFit/>
-          </a:bodyPr>
-          <a:lstStyle/>
-          <a:p>
-            <a:pPr>
-              <a:spcAft>
-                <a:spcPts val="1000"/>
-              </a:spcAft>
-              <a:defRPr sz="1800">
-                <a:solidFill>
-                  <a:srgbClr val="0A0A0A"/>
-                </a:solidFill>
-              </a:defRPr>
-            </a:pPr>
-            <a:r>
-              <a:t>•  Every one of 24 public exemplars is measured independently, not summarized into one repo-wide percentage.</a:t>
-            </a:r>
-          </a:p>
-          <a:p>
-            <a:pPr>
-              <a:spcAft>
-                <a:spcPts val="1000"/>
-              </a:spcAft>
-              <a:defRPr sz="1800">
-                <a:solidFill>
-                  <a:srgbClr val="0A0A0A"/>
-                </a:solidFill>
-              </a:defRPr>
-            </a:pPr>
-            <a:r>
-              <a:t>•  The chart on the next slide is generated from the same docs/_generated/COUNTS.md factsheet this deck's own 97.66% figure comes from — one source of truth, two presentations.</a:t>
-            </a:r>
-          </a:p>
-        </p:txBody>
-      </p:sp>
+              <a:t>The integrity stack, gate by gate</a:t>
+            </a:r>
+          </a:p>
+        </p:txBody>
+      </p:sp>
+      <p:pic>
+        <p:nvPicPr>
+          <p:cNvPr id="4" name="Picture 3" descr="integrity_stack.png"/>
+          <p:cNvPicPr>
+            <a:picLocks noChangeAspect="1"/>
+          </p:cNvPicPr>
+          <p:nvPr/>
+        </p:nvPicPr>
+        <p:blipFill>
+          <a:blip r:embed="rId2"/>
+          <a:stretch>
+            <a:fillRect/>
+          </a:stretch>
+        </p:blipFill>
+        <p:spPr>
+          <a:xfrm>
+            <a:off x="1882463" y="914400"/>
+            <a:ext cx="5379072" cy="3415284"/>
+          </a:xfrm>
+          <a:prstGeom prst="rect">
+            <a:avLst/>
+          </a:prstGeom>
+        </p:spPr>
+      </p:pic>
       <p:sp>
         <p:nvSpPr>
           <p:cNvPr id="5" name="TextBox 4"/>
@@ -7053,9 +7302,9 @@
                 <a:solidFill>
                   <a:srgbClr val="8A8F99"/>
                 </a:solidFill>
-                <a:hlinkClick r:id="rId2"/>
+                <a:hlinkClick r:id="rId3"/>
               </a:rPr>
-              <a:t>Source: docs/_generated/COUNTS.md</a:t>
+              <a:t>Source: projects/templates/template_pitch_deck/src/token_resolution.py</a:t>
             </a:r>
           </a:p>
         </p:txBody>
@@ -7063,7 +7312,7 @@
       <p:pic>
         <p:nvPicPr>
           <p:cNvPr id="6" name="Picture 5" descr="image.png">
-            <a:hlinkClick r:id="rId4"/>
+            <a:hlinkClick r:id="rId5"/>
           </p:cNvPr>
           <p:cNvPicPr>
             <a:picLocks noChangeAspect="1"/>
@@ -7071,7 +7320,7 @@
           <p:nvPr/>
         </p:nvPicPr>
         <p:blipFill>
-          <a:blip r:embed="rId3"/>
+          <a:blip r:embed="rId4"/>
           <a:stretch>
             <a:fillRect/>
           </a:stretch>
@@ -7157,7 +7406,7 @@
         <p:spPr>
           <a:xfrm>
             <a:off x="0" y="0"/>
-            <a:ext cx="9144000" cy="685800"/>
+            <a:ext cx="9144000" cy="822960"/>
           </a:xfrm>
           <a:prstGeom prst="rect">
             <a:avLst/>
@@ -7185,45 +7434,97 @@
           </a:fontRef>
         </p:style>
         <p:txBody>
-          <a:bodyPr rtlCol="0" anchor="ctr" lIns="502920"/>
+          <a:bodyPr rtlCol="0" anchor="ctr" wrap="none" lIns="502920" rIns="502920">
+            <a:noAutofit/>
+          </a:bodyPr>
           <a:lstStyle/>
           <a:p>
             <a:pPr algn="ctr"/>
             <a:r>
-              <a:rPr sz="2200" b="1">
+              <a:rPr sz="2400" b="1">
                 <a:solidFill>
                   <a:srgbClr val="FFFFFF"/>
                 </a:solidFill>
+                <a:latin typeface="Helvetica"/>
               </a:rPr>
-              <a:t>Per-exemplar coverage, measured live</a:t>
-            </a:r>
-          </a:p>
-        </p:txBody>
-      </p:sp>
-      <p:pic>
-        <p:nvPicPr>
-          <p:cNvPr id="4" name="Picture 3" descr="coverage_by_exemplar.png"/>
-          <p:cNvPicPr>
-            <a:picLocks noChangeAspect="1"/>
-          </p:cNvPicPr>
-          <p:nvPr/>
-        </p:nvPicPr>
-        <p:blipFill>
-          <a:blip r:embed="rId2"/>
-          <a:stretch>
-            <a:fillRect/>
-          </a:stretch>
-        </p:blipFill>
-        <p:spPr>
-          <a:xfrm>
-            <a:off x="914400" y="914400"/>
-            <a:ext cx="7315200" cy="5107340"/>
-          </a:xfrm>
-          <a:prstGeom prst="rect">
-            <a:avLst/>
-          </a:prstGeom>
-        </p:spPr>
-      </p:pic>
+              <a:t>Coverage isn't a headline number</a:t>
+            </a:r>
+          </a:p>
+        </p:txBody>
+      </p:sp>
+      <p:sp>
+        <p:nvSpPr>
+          <p:cNvPr id="4" name="TextBox 3"/>
+          <p:cNvSpPr txBox="1"/>
+          <p:nvPr/>
+        </p:nvSpPr>
+        <p:spPr>
+          <a:xfrm>
+            <a:off x="502920" y="1070305"/>
+            <a:ext cx="8138160" cy="1383411"/>
+          </a:xfrm>
+          <a:prstGeom prst="rect">
+            <a:avLst/>
+          </a:prstGeom>
+          <a:noFill/>
+        </p:spPr>
+        <p:txBody>
+          <a:bodyPr wrap="none" anchor="t" lIns="0" rIns="0" tIns="0" bIns="0">
+            <a:noAutofit/>
+          </a:bodyPr>
+          <a:lstStyle/>
+          <a:p>
+            <a:pPr>
+              <a:lnSpc>
+                <a:spcPts val="2100"/>
+              </a:lnSpc>
+              <a:spcAft>
+                <a:spcPts val="828"/>
+              </a:spcAft>
+              <a:defRPr sz="1800">
+                <a:solidFill>
+                  <a:srgbClr val="0A0A0A"/>
+                </a:solidFill>
+                <a:latin typeface="Helvetica"/>
+              </a:defRPr>
+            </a:pPr>
+            <a:r>
+              <a:t>• Every one of 24 public exemplars is measured independently, not summarized</a:t>
+            </a:r>
+            <a:br/>
+            <a:r>
+              <a:t>into one repo-wide percentage.</a:t>
+            </a:r>
+          </a:p>
+          <a:p>
+            <a:pPr>
+              <a:lnSpc>
+                <a:spcPts val="2100"/>
+              </a:lnSpc>
+              <a:spcAft>
+                <a:spcPts val="0"/>
+              </a:spcAft>
+              <a:defRPr sz="1800">
+                <a:solidFill>
+                  <a:srgbClr val="0A0A0A"/>
+                </a:solidFill>
+                <a:latin typeface="Helvetica"/>
+              </a:defRPr>
+            </a:pPr>
+            <a:r>
+              <a:t>• The chart on the next slide is generated from the same</a:t>
+            </a:r>
+            <a:br/>
+            <a:r>
+              <a:t>docs/_generated/COUNTS.md factsheet this deck's own 97.66% figure comes</a:t>
+            </a:r>
+            <a:br/>
+            <a:r>
+              <a:t>from — one source of truth, two presentations.</a:t>
+            </a:r>
+          </a:p>
+        </p:txBody>
+      </p:sp>
       <p:sp>
         <p:nvSpPr>
           <p:cNvPr id="5" name="TextBox 4"/>
@@ -7251,7 +7552,7 @@
                 <a:solidFill>
                   <a:srgbClr val="8A8F99"/>
                 </a:solidFill>
-                <a:hlinkClick r:id="rId3"/>
+                <a:hlinkClick r:id="rId2"/>
               </a:rPr>
               <a:t>Source: docs/_generated/COUNTS.md</a:t>
             </a:r>
@@ -7261,7 +7562,7 @@
       <p:pic>
         <p:nvPicPr>
           <p:cNvPr id="6" name="Picture 5" descr="image.png">
-            <a:hlinkClick r:id="rId5"/>
+            <a:hlinkClick r:id="rId4"/>
           </p:cNvPr>
           <p:cNvPicPr>
             <a:picLocks noChangeAspect="1"/>
@@ -7269,7 +7570,7 @@
           <p:nvPr/>
         </p:nvPicPr>
         <p:blipFill>
-          <a:blip r:embed="rId4"/>
+          <a:blip r:embed="rId3"/>
           <a:stretch>
             <a:fillRect/>
           </a:stretch>
@@ -7383,7 +7684,9 @@
           </a:fontRef>
         </p:style>
         <p:txBody>
-          <a:bodyPr rtlCol="0" anchor="ctr" lIns="502920"/>
+          <a:bodyPr rtlCol="0" anchor="ctr" wrap="none" lIns="502920" rIns="502920">
+            <a:noAutofit/>
+          </a:bodyPr>
           <a:lstStyle/>
           <a:p>
             <a:pPr algn="ctr"/>
@@ -7392,15 +7695,16 @@
                 <a:solidFill>
                   <a:srgbClr val="FFFFFF"/>
                 </a:solidFill>
+                <a:latin typeface="Helvetica"/>
               </a:rPr>
-              <a:t>Test volume and coverage aren't a tradeoff</a:t>
+              <a:t>Per-exemplar coverage, measured live</a:t>
             </a:r>
           </a:p>
         </p:txBody>
       </p:sp>
       <p:pic>
         <p:nvPicPr>
-          <p:cNvPr id="4" name="Picture 3" descr="test_count_vs_coverage.png"/>
+          <p:cNvPr id="4" name="Picture 3" descr="coverage_by_exemplar.png"/>
           <p:cNvPicPr>
             <a:picLocks noChangeAspect="1"/>
           </p:cNvPicPr>
@@ -7414,8 +7718,8 @@
         </p:blipFill>
         <p:spPr>
           <a:xfrm>
-            <a:off x="914400" y="914400"/>
-            <a:ext cx="7315200" cy="5283200"/>
+            <a:off x="2126158" y="914400"/>
+            <a:ext cx="4891682" cy="3415284"/>
           </a:xfrm>
           <a:prstGeom prst="rect">
             <a:avLst/>
@@ -7553,7 +7857,7 @@
         <p:spPr>
           <a:xfrm>
             <a:off x="0" y="0"/>
-            <a:ext cx="9144000" cy="822960"/>
+            <a:ext cx="9144000" cy="685800"/>
           </a:xfrm>
           <a:prstGeom prst="rect">
             <a:avLst/>
@@ -7581,89 +7885,48 @@
           </a:fontRef>
         </p:style>
         <p:txBody>
-          <a:bodyPr rtlCol="0" anchor="ctr" lIns="502920"/>
+          <a:bodyPr rtlCol="0" anchor="ctr" wrap="none" lIns="502920" rIns="502920">
+            <a:noAutofit/>
+          </a:bodyPr>
           <a:lstStyle/>
           <a:p>
             <a:pPr algn="ctr"/>
             <a:r>
-              <a:rPr sz="2400" b="1">
+              <a:rPr sz="2200" b="1">
                 <a:solidFill>
                   <a:srgbClr val="FFFFFF"/>
                 </a:solidFill>
+                <a:latin typeface="Helvetica"/>
               </a:rPr>
-              <a:t>This deck audits itself</a:t>
-            </a:r>
-          </a:p>
-        </p:txBody>
-      </p:sp>
-      <p:sp>
-        <p:nvSpPr>
-          <p:cNvPr id="4" name="TextBox 3"/>
-          <p:cNvSpPr txBox="1"/>
-          <p:nvPr/>
-        </p:nvSpPr>
-        <p:spPr>
-          <a:xfrm>
-            <a:off x="502920" y="1097280"/>
-            <a:ext cx="8138160" cy="2560320"/>
-          </a:xfrm>
-          <a:prstGeom prst="rect">
-            <a:avLst/>
-          </a:prstGeom>
-          <a:noFill/>
-        </p:spPr>
-        <p:txBody>
-          <a:bodyPr wrap="square">
-            <a:spAutoFit/>
-          </a:bodyPr>
-          <a:lstStyle/>
-          <a:p>
-            <a:pPr>
-              <a:spcAft>
-                <a:spcPts val="1000"/>
-              </a:spcAft>
-              <a:defRPr sz="1800">
-                <a:solidFill>
-                  <a:srgbClr val="0A0A0A"/>
-                </a:solidFill>
-              </a:defRPr>
-            </a:pPr>
-            <a:r>
-              <a:t>•  src/token_resolution.py fails the build on any unresolved double-curly-brace placeholder — the same discipline this slide's own template_template token was resolved by.</a:t>
-            </a:r>
-          </a:p>
-          <a:p>
-            <a:pPr>
-              <a:spcAft>
-                <a:spcPts val="1000"/>
-              </a:spcAft>
-              <a:defRPr sz="1800">
-                <a:solidFill>
-                  <a:srgbClr val="0A0A0A"/>
-                </a:solidFill>
-              </a:defRPr>
-            </a:pPr>
-            <a:r>
-              <a:t>•  src/cliche_lint.py and src/diligence_audit.py both run inside render_orchestration.py itself, before that deck length's own PDF/PPTX is written — a slide referencing a live-sourced token with no citation blocks that length's render, it does not just fail a separate, skippable check.</a:t>
-            </a:r>
-          </a:p>
-          <a:p>
-            <a:pPr>
-              <a:spcAft>
-                <a:spcPts val="1000"/>
-              </a:spcAft>
-              <a:defRPr sz="1800">
-                <a:solidFill>
-                  <a:srgbClr val="0A0A0A"/>
-                </a:solidFill>
-              </a:defRPr>
-            </a:pPr>
-            <a:r>
-              <a:t>•  None of these checks are generic infrastructure — they are this project's own src/, built specifically because a pitch deck is exactly the kind of document that tempts unverifiable claims.</a:t>
-            </a:r>
-          </a:p>
-        </p:txBody>
-      </p:sp>
+              <a:t>Test volume and coverage aren't a tradeoff</a:t>
+            </a:r>
+          </a:p>
+        </p:txBody>
+      </p:sp>
+      <p:pic>
+        <p:nvPicPr>
+          <p:cNvPr id="4" name="Picture 3" descr="test_count_vs_coverage.png"/>
+          <p:cNvPicPr>
+            <a:picLocks noChangeAspect="1"/>
+          </p:cNvPicPr>
+          <p:nvPr/>
+        </p:nvPicPr>
+        <p:blipFill>
+          <a:blip r:embed="rId2"/>
+          <a:stretch>
+            <a:fillRect/>
+          </a:stretch>
+        </p:blipFill>
+        <p:spPr>
+          <a:xfrm>
+            <a:off x="2207572" y="914400"/>
+            <a:ext cx="4728854" cy="3415284"/>
+          </a:xfrm>
+          <a:prstGeom prst="rect">
+            <a:avLst/>
+          </a:prstGeom>
+        </p:spPr>
+      </p:pic>
       <p:sp>
         <p:nvSpPr>
           <p:cNvPr id="5" name="TextBox 4"/>
@@ -7691,9 +7954,9 @@
                 <a:solidFill>
                   <a:srgbClr val="8A8F99"/>
                 </a:solidFill>
-                <a:hlinkClick r:id="rId2"/>
+                <a:hlinkClick r:id="rId3"/>
               </a:rPr>
-              <a:t>Source: projects/templates/template_pitch_deck/src/diligence_audit.py</a:t>
+              <a:t>Source: docs/_generated/COUNTS.md</a:t>
             </a:r>
           </a:p>
         </p:txBody>
@@ -7701,7 +7964,7 @@
       <p:pic>
         <p:nvPicPr>
           <p:cNvPr id="6" name="Picture 5" descr="image.png">
-            <a:hlinkClick r:id="rId4"/>
+            <a:hlinkClick r:id="rId5"/>
           </p:cNvPr>
           <p:cNvPicPr>
             <a:picLocks noChangeAspect="1"/>
@@ -7709,7 +7972,7 @@
           <p:nvPr/>
         </p:nvPicPr>
         <p:blipFill>
-          <a:blip r:embed="rId3"/>
+          <a:blip r:embed="rId4"/>
           <a:stretch>
             <a:fillRect/>
           </a:stretch>
@@ -7823,7 +8086,9 @@
           </a:fontRef>
         </p:style>
         <p:txBody>
-          <a:bodyPr rtlCol="0" anchor="ctr" lIns="502920"/>
+          <a:bodyPr rtlCol="0" anchor="ctr" wrap="none" lIns="502920" rIns="502920">
+            <a:noAutofit/>
+          </a:bodyPr>
           <a:lstStyle/>
           <a:p>
             <a:pPr algn="ctr"/>
@@ -7832,8 +8097,9 @@
                 <a:solidFill>
                   <a:srgbClr val="FFFFFF"/>
                 </a:solidFill>
+                <a:latin typeface="Helvetica"/>
               </a:rPr>
-              <a:t>The chain of custody: slide → QR → GitHub</a:t>
+              <a:t>This deck audits itself</a:t>
             </a:r>
           </a:p>
         </p:txBody>
@@ -7846,8 +8112,8 @@
         </p:nvSpPr>
         <p:spPr>
           <a:xfrm>
-            <a:off x="502920" y="1097280"/>
-            <a:ext cx="8138160" cy="2560320"/>
+            <a:off x="502920" y="1070305"/>
+            <a:ext cx="8138160" cy="2822066"/>
           </a:xfrm>
           <a:prstGeom prst="rect">
             <a:avLst/>
@@ -7855,53 +8121,93 @@
           <a:noFill/>
         </p:spPr>
         <p:txBody>
-          <a:bodyPr wrap="square">
-            <a:spAutoFit/>
+          <a:bodyPr wrap="none" anchor="t" lIns="0" rIns="0" tIns="0" bIns="0">
+            <a:noAutofit/>
           </a:bodyPr>
           <a:lstStyle/>
           <a:p>
             <a:pPr>
+              <a:lnSpc>
+                <a:spcPts val="2100"/>
+              </a:lnSpc>
               <a:spcAft>
-                <a:spcPts val="1000"/>
+                <a:spcPts val="828"/>
               </a:spcAft>
               <a:defRPr sz="1800">
                 <a:solidFill>
                   <a:srgbClr val="0A0A0A"/>
                 </a:solidFill>
+                <a:latin typeface="Helvetica"/>
               </a:defRPr>
             </a:pPr>
             <a:r>
-              <a:t>•  Every slide in this deck carries its own QR code, linking to a standalone, real Markdown page for that exact slide under output/slides_standalone/.</a:t>
+              <a:t>• src/token_resolution.py fails the build on any unresolved double-curly-brace</a:t>
+            </a:r>
+            <a:br/>
+            <a:r>
+              <a:t>placeholder — the same discipline this slide's own template_template token was</a:t>
+            </a:r>
+            <a:br/>
+            <a:r>
+              <a:t>resolved by.</a:t>
             </a:r>
           </a:p>
           <a:p>
             <a:pPr>
+              <a:lnSpc>
+                <a:spcPts val="2100"/>
+              </a:lnSpc>
               <a:spcAft>
-                <a:spcPts val="1000"/>
+                <a:spcPts val="828"/>
               </a:spcAft>
               <a:defRPr sz="1800">
                 <a:solidFill>
                   <a:srgbClr val="0A0A0A"/>
                 </a:solidFill>
+                <a:latin typeface="Helvetica"/>
               </a:defRPr>
             </a:pPr>
             <a:r>
-              <a:t>•  Once this output/ directory is committed and pushed, a photo of a projected or printed slide can be traced back to its precise source page on GitHub — not just to the deck as a whole. Locally, the generated page already exists; the QR only resolves once it is actually published.</a:t>
+              <a:t>• src/cliche_lint.py and src/diligence_audit.py both run inside</a:t>
+            </a:r>
+            <a:br/>
+            <a:r>
+              <a:t>render_orchestration.py itself, before that deck length's own PDF/PPTX is</a:t>
+            </a:r>
+            <a:br/>
+            <a:r>
+              <a:t>written — a slide referencing a live-sourced token with no citation blocks that</a:t>
+            </a:r>
+            <a:br/>
+            <a:r>
+              <a:t>length's render, it does not just fail a separate, skippable check.</a:t>
             </a:r>
           </a:p>
           <a:p>
             <a:pPr>
+              <a:lnSpc>
+                <a:spcPts val="2100"/>
+              </a:lnSpc>
               <a:spcAft>
-                <a:spcPts val="1000"/>
+                <a:spcPts val="0"/>
               </a:spcAft>
               <a:defRPr sz="1800">
                 <a:solidFill>
                   <a:srgbClr val="0A0A0A"/>
                 </a:solidFill>
+                <a:latin typeface="Helvetica"/>
               </a:defRPr>
             </a:pPr>
             <a:r>
-              <a:t>•  Mechanically, this is the same source-citation system with one more hop: a citation links out to evidence; the QR links to the slide's own generated page, which repeats that same citation.</a:t>
+              <a:t>• None of these checks are generic infrastructure — they are this project's own</a:t>
+            </a:r>
+            <a:br/>
+            <a:r>
+              <a:t>src/, built specifically because a pitch deck is exactly the kind of document that</a:t>
+            </a:r>
+            <a:br/>
+            <a:r>
+              <a:t>tempts unverifiable claims.</a:t>
             </a:r>
           </a:p>
         </p:txBody>
@@ -7935,7 +8241,7 @@
                 </a:solidFill>
                 <a:hlinkClick r:id="rId2"/>
               </a:rPr>
-              <a:t>Source: projects/templates/template_pitch_deck/src/standalone_slides.py</a:t>
+              <a:t>Source: projects/templates/template_pitch_deck/src/diligence_audit.py</a:t>
             </a:r>
           </a:p>
         </p:txBody>
@@ -8065,7 +8371,9 @@
           </a:fontRef>
         </p:style>
         <p:txBody>
-          <a:bodyPr rtlCol="0" anchor="ctr" lIns="502920"/>
+          <a:bodyPr rtlCol="0" anchor="ctr" wrap="none" lIns="502920" rIns="502920">
+            <a:noAutofit/>
+          </a:bodyPr>
           <a:lstStyle/>
           <a:p>
             <a:pPr algn="ctr"/>
@@ -8074,8 +8382,9 @@
                 <a:solidFill>
                   <a:srgbClr val="FFFFFF"/>
                 </a:solidFill>
+                <a:latin typeface="Helvetica"/>
               </a:rPr>
-              <a:t>Cite this deck</a:t>
+              <a:t>The chain of custody: slide → QR → GitHub</a:t>
             </a:r>
           </a:p>
         </p:txBody>
@@ -8088,8 +8397,8 @@
         </p:nvSpPr>
         <p:spPr>
           <a:xfrm>
-            <a:off x="502920" y="1097280"/>
-            <a:ext cx="8138160" cy="2368296"/>
+            <a:off x="502920" y="1070305"/>
+            <a:ext cx="8138160" cy="2555366"/>
           </a:xfrm>
           <a:prstGeom prst="rect">
             <a:avLst/>
@@ -8097,53 +8406,89 @@
           <a:noFill/>
         </p:spPr>
         <p:txBody>
-          <a:bodyPr wrap="square">
-            <a:spAutoFit/>
+          <a:bodyPr wrap="none" anchor="t" lIns="0" rIns="0" tIns="0" bIns="0">
+            <a:noAutofit/>
           </a:bodyPr>
           <a:lstStyle/>
           <a:p>
             <a:pPr>
+              <a:lnSpc>
+                <a:spcPts val="2100"/>
+              </a:lnSpc>
               <a:spcAft>
-                <a:spcPts val="1000"/>
+                <a:spcPts val="828"/>
               </a:spcAft>
               <a:defRPr sz="1800">
                 <a:solidFill>
                   <a:srgbClr val="0A0A0A"/>
                 </a:solidFill>
+                <a:latin typeface="Helvetica"/>
               </a:defRPr>
             </a:pPr>
             <a:r>
-              <a:t>•  This pitch deck is its own exemplar in the same monorepo — it has its own src/, tests, and citable identity, distinct from the DOI of template_template, the project it pitches.</a:t>
+              <a:t>• Every slide in this deck carries its own QR code, linking to a standalone, real</a:t>
+            </a:r>
+            <a:br/>
+            <a:r>
+              <a:t>Markdown page for that exact slide under output/slides_standalone/.</a:t>
             </a:r>
           </a:p>
           <a:p>
             <a:pPr>
+              <a:lnSpc>
+                <a:spcPts val="2100"/>
+              </a:lnSpc>
               <a:spcAft>
-                <a:spcPts val="1000"/>
+                <a:spcPts val="828"/>
               </a:spcAft>
               <a:defRPr sz="1800">
                 <a:solidFill>
                   <a:srgbClr val="0A0A0A"/>
                 </a:solidFill>
+                <a:latin typeface="Helvetica"/>
               </a:defRPr>
             </a:pPr>
             <a:r>
-              <a:t>•  This deck's own DOI: 10.5281/zenodo.21281509.</a:t>
+              <a:t>• Once this output/ directory is committed and pushed, a photo of a projected or</a:t>
+            </a:r>
+            <a:br/>
+            <a:r>
+              <a:t>printed slide can be traced back to its precise source page on GitHub — not just</a:t>
+            </a:r>
+            <a:br/>
+            <a:r>
+              <a:t>to the deck as a whole. Locally, the generated page already exists; the QR only</a:t>
+            </a:r>
+            <a:br/>
+            <a:r>
+              <a:t>resolves once it is actually published.</a:t>
             </a:r>
           </a:p>
           <a:p>
             <a:pPr>
+              <a:lnSpc>
+                <a:spcPts val="2100"/>
+              </a:lnSpc>
               <a:spcAft>
-                <a:spcPts val="1000"/>
+                <a:spcPts val="0"/>
               </a:spcAft>
               <a:defRPr sz="1800">
                 <a:solidFill>
                   <a:srgbClr val="0A0A0A"/>
                 </a:solidFill>
+                <a:latin typeface="Helvetica"/>
               </a:defRPr>
             </a:pPr>
             <a:r>
-              <a:t>•  That status is read live from this project's own manuscript/config.yaml at render time — the moment a real Zenodo deposit is recorded there, this slide's own text updates on the next regeneration, the same way every other fact in this deck does.</a:t>
+              <a:t>• Mechanically, this is the same source-citation system with one more hop: a</a:t>
+            </a:r>
+            <a:br/>
+            <a:r>
+              <a:t>citation links out to evidence; the QR links to the slide's own generated page,</a:t>
+            </a:r>
+            <a:br/>
+            <a:r>
+              <a:t>which repeats that same citation.</a:t>
             </a:r>
           </a:p>
         </p:txBody>
@@ -8177,7 +8522,7 @@
                 </a:solidFill>
                 <a:hlinkClick r:id="rId2"/>
               </a:rPr>
-              <a:t>Source: projects/templates/template_pitch_deck/manuscript/config.yaml</a:t>
+              <a:t>Source: projects/templates/template_pitch_deck/src/standalone_slides.py</a:t>
             </a:r>
           </a:p>
         </p:txBody>
@@ -8278,7 +8623,7 @@
         </p:nvSpPr>
         <p:spPr>
           <a:xfrm>
-            <a:off x="502920" y="2514600"/>
+            <a:off x="502920" y="2559050"/>
             <a:ext cx="8138160" cy="38100"/>
           </a:xfrm>
           <a:prstGeom prst="rect">
@@ -8322,8 +8667,8 @@
         </p:nvSpPr>
         <p:spPr>
           <a:xfrm>
-            <a:off x="502920" y="2103120"/>
-            <a:ext cx="8138160" cy="914400"/>
+            <a:off x="502920" y="1918970"/>
+            <a:ext cx="8138160" cy="502920"/>
           </a:xfrm>
           <a:prstGeom prst="rect">
             <a:avLst/>
@@ -8331,16 +8676,22 @@
           <a:noFill/>
         </p:spPr>
         <p:txBody>
-          <a:bodyPr wrap="square">
-            <a:spAutoFit/>
+          <a:bodyPr wrap="none" anchor="t" lIns="0" rIns="0" tIns="0" bIns="0">
+            <a:noAutofit/>
           </a:bodyPr>
           <a:lstStyle/>
           <a:p>
+            <a:pPr>
+              <a:lnSpc>
+                <a:spcPts val="3300"/>
+              </a:lnSpc>
+            </a:pPr>
             <a:r>
               <a:rPr sz="3300" b="1">
                 <a:solidFill>
                   <a:srgbClr val="0A0A0A"/>
                 </a:solidFill>
+                <a:latin typeface="Helvetica"/>
               </a:rPr>
               <a:t>Landscape</a:t>
             </a:r>
@@ -8443,14 +8794,14 @@
         </p:nvSpPr>
         <p:spPr>
           <a:xfrm>
-            <a:off x="502920" y="2514600"/>
-            <a:ext cx="8138160" cy="38100"/>
+            <a:off x="0" y="0"/>
+            <a:ext cx="9144000" cy="822960"/>
           </a:xfrm>
           <a:prstGeom prst="rect">
             <a:avLst/>
           </a:prstGeom>
           <a:solidFill>
-            <a:srgbClr val="B3131A"/>
+            <a:srgbClr val="0A0A0A"/>
           </a:solidFill>
           <a:ln>
             <a:noFill/>
@@ -8472,10 +8823,21 @@
           </a:fontRef>
         </p:style>
         <p:txBody>
-          <a:bodyPr rtlCol="0" anchor="ctr"/>
+          <a:bodyPr rtlCol="0" anchor="ctr" wrap="none" lIns="502920" rIns="502920">
+            <a:noAutofit/>
+          </a:bodyPr>
           <a:lstStyle/>
           <a:p>
             <a:pPr algn="ctr"/>
+            <a:r>
+              <a:rPr sz="2400" b="1">
+                <a:solidFill>
+                  <a:srgbClr val="FFFFFF"/>
+                </a:solidFill>
+                <a:latin typeface="Helvetica"/>
+              </a:rPr>
+              <a:t>Cite this deck</a:t>
+            </a:r>
           </a:p>
         </p:txBody>
       </p:sp>
@@ -8487,8 +8849,8 @@
         </p:nvSpPr>
         <p:spPr>
           <a:xfrm>
-            <a:off x="502920" y="2103120"/>
-            <a:ext cx="8138160" cy="914400"/>
+            <a:off x="502920" y="1070305"/>
+            <a:ext cx="8138160" cy="2288666"/>
           </a:xfrm>
           <a:prstGeom prst="rect">
             <a:avLst/>
@@ -8496,26 +8858,127 @@
           <a:noFill/>
         </p:spPr>
         <p:txBody>
-          <a:bodyPr wrap="square">
+          <a:bodyPr wrap="none" anchor="t" lIns="0" rIns="0" tIns="0" bIns="0">
+            <a:noAutofit/>
+          </a:bodyPr>
+          <a:lstStyle/>
+          <a:p>
+            <a:pPr>
+              <a:lnSpc>
+                <a:spcPts val="2100"/>
+              </a:lnSpc>
+              <a:spcAft>
+                <a:spcPts val="828"/>
+              </a:spcAft>
+              <a:defRPr sz="1800">
+                <a:solidFill>
+                  <a:srgbClr val="0A0A0A"/>
+                </a:solidFill>
+                <a:latin typeface="Helvetica"/>
+              </a:defRPr>
+            </a:pPr>
+            <a:r>
+              <a:t>• This pitch deck is its own exemplar in the same monorepo — it has its own</a:t>
+            </a:r>
+            <a:br/>
+            <a:r>
+              <a:t>src/, tests, and citable identity, distinct from the DOI of template_template, the</a:t>
+            </a:r>
+            <a:br/>
+            <a:r>
+              <a:t>project it pitches.</a:t>
+            </a:r>
+          </a:p>
+          <a:p>
+            <a:pPr>
+              <a:lnSpc>
+                <a:spcPts val="2100"/>
+              </a:lnSpc>
+              <a:spcAft>
+                <a:spcPts val="828"/>
+              </a:spcAft>
+              <a:defRPr sz="1800">
+                <a:solidFill>
+                  <a:srgbClr val="0A0A0A"/>
+                </a:solidFill>
+                <a:latin typeface="Helvetica"/>
+              </a:defRPr>
+            </a:pPr>
+            <a:r>
+              <a:t>• This deck's own DOI: 10.5281/zenodo.21281509.</a:t>
+            </a:r>
+          </a:p>
+          <a:p>
+            <a:pPr>
+              <a:lnSpc>
+                <a:spcPts val="2100"/>
+              </a:lnSpc>
+              <a:spcAft>
+                <a:spcPts val="0"/>
+              </a:spcAft>
+              <a:defRPr sz="1800">
+                <a:solidFill>
+                  <a:srgbClr val="0A0A0A"/>
+                </a:solidFill>
+                <a:latin typeface="Helvetica"/>
+              </a:defRPr>
+            </a:pPr>
+            <a:r>
+              <a:t>• That status is read live from this project's own manuscript/config.yaml at</a:t>
+            </a:r>
+            <a:br/>
+            <a:r>
+              <a:t>render time — the moment a real Zenodo deposit is recorded there, this slide's</a:t>
+            </a:r>
+            <a:br/>
+            <a:r>
+              <a:t>own text updates on the next regeneration, the same way every other fact in this</a:t>
+            </a:r>
+            <a:br/>
+            <a:r>
+              <a:t>deck does.</a:t>
+            </a:r>
+          </a:p>
+        </p:txBody>
+      </p:sp>
+      <p:sp>
+        <p:nvSpPr>
+          <p:cNvPr id="5" name="TextBox 4"/>
+          <p:cNvSpPr txBox="1"/>
+          <p:nvPr/>
+        </p:nvSpPr>
+        <p:spPr>
+          <a:xfrm>
+            <a:off x="502920" y="4823460"/>
+            <a:ext cx="5486400" cy="274320"/>
+          </a:xfrm>
+          <a:prstGeom prst="rect">
+            <a:avLst/>
+          </a:prstGeom>
+          <a:noFill/>
+        </p:spPr>
+        <p:txBody>
+          <a:bodyPr wrap="none">
             <a:spAutoFit/>
           </a:bodyPr>
           <a:lstStyle/>
           <a:p>
             <a:r>
-              <a:rPr sz="2800" b="1">
-                <a:solidFill>
-                  <a:srgbClr val="0A0A0A"/>
-                </a:solidFill>
+              <a:rPr sz="900" i="1">
+                <a:solidFill>
+                  <a:srgbClr val="8A8F99"/>
+                </a:solidFill>
+                <a:hlinkClick r:id="rId2"/>
               </a:rPr>
-              <a:t>What's actually inside infrastructure/</a:t>
+              <a:t>Source: projects/templates/template_pitch_deck/manuscript/config.yaml</a:t>
             </a:r>
           </a:p>
         </p:txBody>
       </p:sp>
       <p:pic>
         <p:nvPicPr>
-          <p:cNvPr id="5" name="Picture 4" descr="image.png">
-            <a:hlinkClick r:id="rId3"/>
+          <p:cNvPr id="6" name="Picture 5" descr="image.png">
+            <a:hlinkClick r:id="rId4"/>
           </p:cNvPr>
           <p:cNvPicPr>
             <a:picLocks noChangeAspect="1"/>
@@ -8523,7 +8986,7 @@
           <p:nvPr/>
         </p:nvPicPr>
         <p:blipFill>
-          <a:blip r:embed="rId2"/>
+          <a:blip r:embed="rId3"/>
           <a:stretch>
             <a:fillRect/>
           </a:stretch>
@@ -8608,14 +9071,14 @@
         </p:nvSpPr>
         <p:spPr>
           <a:xfrm>
-            <a:off x="0" y="0"/>
-            <a:ext cx="9144000" cy="822960"/>
+            <a:off x="502920" y="2559050"/>
+            <a:ext cx="8138160" cy="38100"/>
           </a:xfrm>
           <a:prstGeom prst="rect">
             <a:avLst/>
           </a:prstGeom>
           <a:solidFill>
-            <a:srgbClr val="0A0A0A"/>
+            <a:srgbClr val="B3131A"/>
           </a:solidFill>
           <a:ln>
             <a:noFill/>
@@ -8637,18 +9100,10 @@
           </a:fontRef>
         </p:style>
         <p:txBody>
-          <a:bodyPr rtlCol="0" anchor="ctr" lIns="502920"/>
+          <a:bodyPr rtlCol="0" anchor="ctr"/>
           <a:lstStyle/>
           <a:p>
             <a:pPr algn="ctr"/>
-            <a:r>
-              <a:rPr sz="2400" b="1">
-                <a:solidFill>
-                  <a:srgbClr val="FFFFFF"/>
-                </a:solidFill>
-              </a:rPr>
-              <a:t>Not a black box</a:t>
-            </a:r>
           </a:p>
         </p:txBody>
       </p:sp>
@@ -8660,8 +9115,8 @@
         </p:nvSpPr>
         <p:spPr>
           <a:xfrm>
-            <a:off x="502920" y="1097280"/>
-            <a:ext cx="8138160" cy="2560320"/>
+            <a:off x="502920" y="1918970"/>
+            <a:ext cx="8138160" cy="502920"/>
           </a:xfrm>
           <a:prstGeom prst="rect">
             <a:avLst/>
@@ -8669,110 +9124,32 @@
           <a:noFill/>
         </p:spPr>
         <p:txBody>
-          <a:bodyPr wrap="square">
-            <a:spAutoFit/>
+          <a:bodyPr wrap="none" anchor="t" lIns="0" rIns="0" tIns="0" bIns="0">
+            <a:noAutofit/>
           </a:bodyPr>
           <a:lstStyle/>
           <a:p>
             <a:pPr>
-              <a:spcAft>
-                <a:spcPts val="1000"/>
-              </a:spcAft>
-              <a:defRPr sz="1800">
+              <a:lnSpc>
+                <a:spcPts val="3300"/>
+              </a:lnSpc>
+            </a:pPr>
+            <a:r>
+              <a:rPr sz="3300" b="1">
                 <a:solidFill>
                   <a:srgbClr val="0A0A0A"/>
                 </a:solidFill>
-              </a:defRPr>
-            </a:pPr>
-            <a:r>
-              <a:t>•  25 importable subpackages, 744 tracked Python files total under infrastructure/ — a real inventory anyone can `git ls-files` themselves, not a claimed abstraction.</a:t>
-            </a:r>
-          </a:p>
-          <a:p>
-            <a:pPr>
-              <a:spcAft>
-                <a:spcPts val="1000"/>
-              </a:spcAft>
-              <a:defRPr sz="1800">
-                <a:solidFill>
-                  <a:srgbClr val="0A0A0A"/>
-                </a:solidFill>
-              </a:defRPr>
-            </a:pPr>
-            <a:r>
-              <a:t>•  The largest single subpackage, core, holds 128 files — still a minority of the whole, not a monolith wearing a modular label.</a:t>
-            </a:r>
-          </a:p>
-          <a:p>
-            <a:pPr>
-              <a:spcAft>
-                <a:spcPts val="1000"/>
-              </a:spcAft>
-              <a:defRPr sz="1800">
-                <a:solidFill>
-                  <a:srgbClr val="0A0A0A"/>
-                </a:solidFill>
-              </a:defRPr>
-            </a:pPr>
-            <a:r>
-              <a:t>•  Every number on this slide is computed live by src/infra_facts.py at render time, reusing the exact same counters docs/_generated/COUNTS.md is built from.</a:t>
-            </a:r>
-          </a:p>
-          <a:p>
-            <a:pPr>
-              <a:spcAft>
-                <a:spcPts val="1000"/>
-              </a:spcAft>
-              <a:defRPr sz="1800">
-                <a:solidFill>
-                  <a:srgbClr val="0A0A0A"/>
-                </a:solidFill>
-              </a:defRPr>
-            </a:pPr>
-            <a:r>
-              <a:t>•  The chart on the next slide shows a slightly narrower total — it only counts files inside an importable subpackage, excluding 2 top-level file(s) (infrastructure/__init__.py, mcp_server.py) that do not belong to any subpackage.</a:t>
-            </a:r>
-          </a:p>
-        </p:txBody>
-      </p:sp>
-      <p:sp>
-        <p:nvSpPr>
-          <p:cNvPr id="5" name="TextBox 4"/>
-          <p:cNvSpPr txBox="1"/>
-          <p:nvPr/>
-        </p:nvSpPr>
-        <p:spPr>
-          <a:xfrm>
-            <a:off x="502920" y="4823460"/>
-            <a:ext cx="5486400" cy="274320"/>
-          </a:xfrm>
-          <a:prstGeom prst="rect">
-            <a:avLst/>
-          </a:prstGeom>
-          <a:noFill/>
-        </p:spPr>
-        <p:txBody>
-          <a:bodyPr wrap="none">
-            <a:spAutoFit/>
-          </a:bodyPr>
-          <a:lstStyle/>
-          <a:p>
-            <a:r>
-              <a:rPr sz="900" i="1">
-                <a:solidFill>
-                  <a:srgbClr val="8A8F99"/>
-                </a:solidFill>
-                <a:hlinkClick r:id="rId2"/>
+                <a:latin typeface="Helvetica"/>
               </a:rPr>
-              <a:t>Source: projects/templates/template_pitch_deck/src/infra_facts.py</a:t>
+              <a:t>What's actually inside infrastructure/</a:t>
             </a:r>
           </a:p>
         </p:txBody>
       </p:sp>
       <p:pic>
         <p:nvPicPr>
-          <p:cNvPr id="6" name="Picture 5" descr="image.png">
-            <a:hlinkClick r:id="rId4"/>
+          <p:cNvPr id="5" name="Picture 4" descr="image.png">
+            <a:hlinkClick r:id="rId3"/>
           </p:cNvPr>
           <p:cNvPicPr>
             <a:picLocks noChangeAspect="1"/>
@@ -8780,7 +9157,7 @@
           <p:nvPr/>
         </p:nvPicPr>
         <p:blipFill>
-          <a:blip r:embed="rId3"/>
+          <a:blip r:embed="rId2"/>
           <a:stretch>
             <a:fillRect/>
           </a:stretch>
@@ -8866,7 +9243,7 @@
         <p:spPr>
           <a:xfrm>
             <a:off x="0" y="0"/>
-            <a:ext cx="9144000" cy="685800"/>
+            <a:ext cx="9144000" cy="822960"/>
           </a:xfrm>
           <a:prstGeom prst="rect">
             <a:avLst/>
@@ -8894,45 +9271,147 @@
           </a:fontRef>
         </p:style>
         <p:txBody>
-          <a:bodyPr rtlCol="0" anchor="ctr" lIns="502920"/>
+          <a:bodyPr rtlCol="0" anchor="ctr" wrap="none" lIns="502920" rIns="502920">
+            <a:noAutofit/>
+          </a:bodyPr>
           <a:lstStyle/>
           <a:p>
             <a:pPr algn="ctr"/>
             <a:r>
-              <a:rPr sz="2200" b="1">
+              <a:rPr sz="2400" b="1">
                 <a:solidFill>
                   <a:srgbClr val="FFFFFF"/>
                 </a:solidFill>
+                <a:latin typeface="Helvetica"/>
               </a:rPr>
-              <a:t>infrastructure/, by subpackage</a:t>
-            </a:r>
-          </a:p>
-        </p:txBody>
-      </p:sp>
-      <p:pic>
-        <p:nvPicPr>
-          <p:cNvPr id="4" name="Picture 3" descr="infra_subpackage_sizes.png"/>
-          <p:cNvPicPr>
-            <a:picLocks noChangeAspect="1"/>
-          </p:cNvPicPr>
-          <p:nvPr/>
-        </p:nvPicPr>
-        <p:blipFill>
-          <a:blip r:embed="rId2"/>
-          <a:stretch>
-            <a:fillRect/>
-          </a:stretch>
-        </p:blipFill>
-        <p:spPr>
-          <a:xfrm>
-            <a:off x="914400" y="914400"/>
-            <a:ext cx="7315200" cy="7315200"/>
-          </a:xfrm>
-          <a:prstGeom prst="rect">
-            <a:avLst/>
-          </a:prstGeom>
-        </p:spPr>
-      </p:pic>
+              <a:t>Not a black box</a:t>
+            </a:r>
+          </a:p>
+        </p:txBody>
+      </p:sp>
+      <p:sp>
+        <p:nvSpPr>
+          <p:cNvPr id="4" name="TextBox 3"/>
+          <p:cNvSpPr txBox="1"/>
+          <p:nvPr/>
+        </p:nvSpPr>
+        <p:spPr>
+          <a:xfrm>
+            <a:off x="502920" y="1070305"/>
+            <a:ext cx="8138160" cy="2927222"/>
+          </a:xfrm>
+          <a:prstGeom prst="rect">
+            <a:avLst/>
+          </a:prstGeom>
+          <a:noFill/>
+        </p:spPr>
+        <p:txBody>
+          <a:bodyPr wrap="none" anchor="t" lIns="0" rIns="0" tIns="0" bIns="0">
+            <a:noAutofit/>
+          </a:bodyPr>
+          <a:lstStyle/>
+          <a:p>
+            <a:pPr>
+              <a:lnSpc>
+                <a:spcPts val="2100"/>
+              </a:lnSpc>
+              <a:spcAft>
+                <a:spcPts val="828"/>
+              </a:spcAft>
+              <a:defRPr sz="1800">
+                <a:solidFill>
+                  <a:srgbClr val="0A0A0A"/>
+                </a:solidFill>
+                <a:latin typeface="Helvetica"/>
+              </a:defRPr>
+            </a:pPr>
+            <a:r>
+              <a:t>• 25 importable subpackages, 752 tracked Python files total under infrastructure/</a:t>
+            </a:r>
+            <a:br/>
+            <a:r>
+              <a:t>— a real inventory anyone can `git ls-files` themselves, not a claimed</a:t>
+            </a:r>
+            <a:br/>
+            <a:r>
+              <a:t>abstraction.</a:t>
+            </a:r>
+          </a:p>
+          <a:p>
+            <a:pPr>
+              <a:lnSpc>
+                <a:spcPts val="2100"/>
+              </a:lnSpc>
+              <a:spcAft>
+                <a:spcPts val="828"/>
+              </a:spcAft>
+              <a:defRPr sz="1800">
+                <a:solidFill>
+                  <a:srgbClr val="0A0A0A"/>
+                </a:solidFill>
+                <a:latin typeface="Helvetica"/>
+              </a:defRPr>
+            </a:pPr>
+            <a:r>
+              <a:t>• The largest single subpackage, core, holds 129 files — still a minority of the</a:t>
+            </a:r>
+            <a:br/>
+            <a:r>
+              <a:t>whole, not a monolith wearing a modular label.</a:t>
+            </a:r>
+          </a:p>
+          <a:p>
+            <a:pPr>
+              <a:lnSpc>
+                <a:spcPts val="2100"/>
+              </a:lnSpc>
+              <a:spcAft>
+                <a:spcPts val="828"/>
+              </a:spcAft>
+              <a:defRPr sz="1800">
+                <a:solidFill>
+                  <a:srgbClr val="0A0A0A"/>
+                </a:solidFill>
+                <a:latin typeface="Helvetica"/>
+              </a:defRPr>
+            </a:pPr>
+            <a:r>
+              <a:t>• Every number on this slide is computed live by src/infra_facts.py at render</a:t>
+            </a:r>
+            <a:br/>
+            <a:r>
+              <a:t>time, reusing the exact same counters docs/_generated/COUNTS.md is built</a:t>
+            </a:r>
+            <a:br/>
+            <a:r>
+              <a:t>from.</a:t>
+            </a:r>
+          </a:p>
+          <a:p>
+            <a:pPr>
+              <a:lnSpc>
+                <a:spcPts val="2100"/>
+              </a:lnSpc>
+              <a:spcAft>
+                <a:spcPts val="0"/>
+              </a:spcAft>
+              <a:defRPr sz="1800">
+                <a:solidFill>
+                  <a:srgbClr val="0A0A0A"/>
+                </a:solidFill>
+                <a:latin typeface="Helvetica"/>
+              </a:defRPr>
+            </a:pPr>
+            <a:r>
+              <a:t>• The next chart narrows the total to importable subpackages, excluding 2</a:t>
+            </a:r>
+            <a:br/>
+            <a:r>
+              <a:t>top-level file(s): infrastructure/__init__.py and mcp_server.py.</a:t>
+            </a:r>
+          </a:p>
+        </p:txBody>
+      </p:sp>
       <p:sp>
         <p:nvSpPr>
           <p:cNvPr id="5" name="TextBox 4"/>
@@ -8960,7 +9439,7 @@
                 <a:solidFill>
                   <a:srgbClr val="8A8F99"/>
                 </a:solidFill>
-                <a:hlinkClick r:id="rId3"/>
+                <a:hlinkClick r:id="rId2"/>
               </a:rPr>
               <a:t>Source: projects/templates/template_pitch_deck/src/infra_facts.py</a:t>
             </a:r>
@@ -8970,7 +9449,7 @@
       <p:pic>
         <p:nvPicPr>
           <p:cNvPr id="6" name="Picture 5" descr="image.png">
-            <a:hlinkClick r:id="rId5"/>
+            <a:hlinkClick r:id="rId4"/>
           </p:cNvPr>
           <p:cNvPicPr>
             <a:picLocks noChangeAspect="1"/>
@@ -8978,7 +9457,7 @@
           <p:nvPr/>
         </p:nvPicPr>
         <p:blipFill>
-          <a:blip r:embed="rId4"/>
+          <a:blip r:embed="rId3"/>
           <a:stretch>
             <a:fillRect/>
           </a:stretch>
@@ -9063,14 +9542,14 @@
         </p:nvSpPr>
         <p:spPr>
           <a:xfrm>
-            <a:off x="502920" y="2514600"/>
-            <a:ext cx="8138160" cy="38100"/>
+            <a:off x="0" y="0"/>
+            <a:ext cx="9144000" cy="685800"/>
           </a:xfrm>
           <a:prstGeom prst="rect">
             <a:avLst/>
           </a:prstGeom>
           <a:solidFill>
-            <a:srgbClr val="B3131A"/>
+            <a:srgbClr val="0A0A0A"/>
           </a:solidFill>
           <a:ln>
             <a:noFill/>
@@ -9092,23 +9571,58 @@
           </a:fontRef>
         </p:style>
         <p:txBody>
-          <a:bodyPr rtlCol="0" anchor="ctr"/>
+          <a:bodyPr rtlCol="0" anchor="ctr" wrap="none" lIns="502920" rIns="502920">
+            <a:noAutofit/>
+          </a:bodyPr>
           <a:lstStyle/>
           <a:p>
             <a:pPr algn="ctr"/>
-          </a:p>
-        </p:txBody>
-      </p:sp>
-      <p:sp>
-        <p:nvSpPr>
-          <p:cNvPr id="4" name="TextBox 3"/>
+            <a:r>
+              <a:rPr sz="2200" b="1">
+                <a:solidFill>
+                  <a:srgbClr val="FFFFFF"/>
+                </a:solidFill>
+                <a:latin typeface="Helvetica"/>
+              </a:rPr>
+              <a:t>infrastructure/, by subpackage</a:t>
+            </a:r>
+          </a:p>
+        </p:txBody>
+      </p:sp>
+      <p:pic>
+        <p:nvPicPr>
+          <p:cNvPr id="4" name="Picture 3" descr="infra_subpackage_sizes.png"/>
+          <p:cNvPicPr>
+            <a:picLocks noChangeAspect="1"/>
+          </p:cNvPicPr>
+          <p:nvPr/>
+        </p:nvPicPr>
+        <p:blipFill>
+          <a:blip r:embed="rId2"/>
+          <a:stretch>
+            <a:fillRect/>
+          </a:stretch>
+        </p:blipFill>
+        <p:spPr>
+          <a:xfrm>
+            <a:off x="2864357" y="914400"/>
+            <a:ext cx="3415284" cy="3415284"/>
+          </a:xfrm>
+          <a:prstGeom prst="rect">
+            <a:avLst/>
+          </a:prstGeom>
+        </p:spPr>
+      </p:pic>
+      <p:sp>
+        <p:nvSpPr>
+          <p:cNvPr id="5" name="TextBox 4"/>
           <p:cNvSpPr txBox="1"/>
           <p:nvPr/>
         </p:nvSpPr>
         <p:spPr>
           <a:xfrm>
-            <a:off x="502920" y="2103120"/>
-            <a:ext cx="8138160" cy="914400"/>
+            <a:off x="502920" y="4823460"/>
+            <a:ext cx="5486400" cy="274320"/>
           </a:xfrm>
           <a:prstGeom prst="rect">
             <a:avLst/>
@@ -9116,26 +9630,27 @@
           <a:noFill/>
         </p:spPr>
         <p:txBody>
-          <a:bodyPr wrap="square">
+          <a:bodyPr wrap="none">
             <a:spAutoFit/>
           </a:bodyPr>
           <a:lstStyle/>
           <a:p>
             <a:r>
-              <a:rPr sz="3300" b="1">
-                <a:solidFill>
-                  <a:srgbClr val="0A0A0A"/>
-                </a:solidFill>
+              <a:rPr sz="900" i="1">
+                <a:solidFill>
+                  <a:srgbClr val="8A8F99"/>
+                </a:solidFill>
+                <a:hlinkClick r:id="rId3"/>
               </a:rPr>
-              <a:t>Roadmap</a:t>
+              <a:t>Source: projects/templates/template_pitch_deck/src/infra_facts.py</a:t>
             </a:r>
           </a:p>
         </p:txBody>
       </p:sp>
       <p:pic>
         <p:nvPicPr>
-          <p:cNvPr id="5" name="Picture 4" descr="image.png">
-            <a:hlinkClick r:id="rId3"/>
+          <p:cNvPr id="6" name="Picture 5" descr="image.png">
+            <a:hlinkClick r:id="rId5"/>
           </p:cNvPr>
           <p:cNvPicPr>
             <a:picLocks noChangeAspect="1"/>
@@ -9143,7 +9658,7 @@
           <p:nvPr/>
         </p:nvPicPr>
         <p:blipFill>
-          <a:blip r:embed="rId2"/>
+          <a:blip r:embed="rId4"/>
           <a:stretch>
             <a:fillRect/>
           </a:stretch>
@@ -9228,14 +9743,14 @@
         </p:nvSpPr>
         <p:spPr>
           <a:xfrm>
-            <a:off x="0" y="0"/>
-            <a:ext cx="9144000" cy="822960"/>
+            <a:off x="502920" y="2559050"/>
+            <a:ext cx="8138160" cy="38100"/>
           </a:xfrm>
           <a:prstGeom prst="rect">
             <a:avLst/>
           </a:prstGeom>
           <a:solidFill>
-            <a:srgbClr val="0A0A0A"/>
+            <a:srgbClr val="B3131A"/>
           </a:solidFill>
           <a:ln>
             <a:noFill/>
@@ -9257,18 +9772,10 @@
           </a:fontRef>
         </p:style>
         <p:txBody>
-          <a:bodyPr rtlCol="0" anchor="ctr" lIns="502920"/>
+          <a:bodyPr rtlCol="0" anchor="ctr"/>
           <a:lstStyle/>
           <a:p>
             <a:pPr algn="ctr"/>
-            <a:r>
-              <a:rPr sz="2400" b="1">
-                <a:solidFill>
-                  <a:srgbClr val="FFFFFF"/>
-                </a:solidFill>
-              </a:rPr>
-              <a:t>What comes next for this exemplar</a:t>
-            </a:r>
           </a:p>
         </p:txBody>
       </p:sp>
@@ -9280,8 +9787,8 @@
         </p:nvSpPr>
         <p:spPr>
           <a:xfrm>
-            <a:off x="502920" y="1097280"/>
-            <a:ext cx="8138160" cy="2112264"/>
+            <a:off x="502920" y="1918970"/>
+            <a:ext cx="8138160" cy="502920"/>
           </a:xfrm>
           <a:prstGeom prst="rect">
             <a:avLst/>
@@ -9289,53 +9796,24 @@
           <a:noFill/>
         </p:spPr>
         <p:txBody>
-          <a:bodyPr wrap="square">
-            <a:spAutoFit/>
+          <a:bodyPr wrap="none" anchor="t" lIns="0" rIns="0" tIns="0" bIns="0">
+            <a:noAutofit/>
           </a:bodyPr>
           <a:lstStyle/>
           <a:p>
             <a:pPr>
-              <a:spcAft>
-                <a:spcPts val="1000"/>
-              </a:spcAft>
-              <a:defRPr sz="1800">
+              <a:lnSpc>
+                <a:spcPts val="3300"/>
+              </a:lnSpc>
+            </a:pPr>
+            <a:r>
+              <a:rPr sz="3300" b="1">
                 <a:solidFill>
                   <a:srgbClr val="0A0A0A"/>
                 </a:solidFill>
-              </a:defRPr>
-            </a:pPr>
-            <a:r>
-              <a:t>•  Extend token-sourced facts beyond one pitch subject to any exemplar in the roster, so a new deck for a different project needs only new content YAML, not new code.</a:t>
-            </a:r>
-          </a:p>
-          <a:p>
-            <a:pPr>
-              <a:spcAft>
-                <a:spcPts val="1000"/>
-              </a:spcAft>
-              <a:defRPr sz="1800">
-                <a:solidFill>
-                  <a:srgbClr val="0A0A0A"/>
-                </a:solidFill>
-              </a:defRPr>
-            </a:pPr>
-            <a:r>
-              <a:t>•  Add a second validated pitch (a broader meta-science-group deck) reusing the same rendering and audit pipeline.</a:t>
-            </a:r>
-          </a:p>
-          <a:p>
-            <a:pPr>
-              <a:spcAft>
-                <a:spcPts val="1000"/>
-              </a:spcAft>
-              <a:defRPr sz="1800">
-                <a:solidFill>
-                  <a:srgbClr val="0A0A0A"/>
-                </a:solidFill>
-              </a:defRPr>
-            </a:pPr>
-            <a:r>
-              <a:t>•  Track deck-generation coverage and drift in the same CI gates that already watch every other public exemplar.</a:t>
+                <a:latin typeface="Helvetica"/>
+              </a:rPr>
+              <a:t>Roadmap</a:t>
             </a:r>
           </a:p>
         </p:txBody>
@@ -9465,7 +9943,9 @@
           </a:fontRef>
         </p:style>
         <p:txBody>
-          <a:bodyPr rtlCol="0" anchor="ctr" lIns="502920"/>
+          <a:bodyPr rtlCol="0" anchor="ctr" wrap="none" lIns="502920" rIns="502920">
+            <a:noAutofit/>
+          </a:bodyPr>
           <a:lstStyle/>
           <a:p>
             <a:pPr algn="ctr"/>
@@ -9474,8 +9954,9 @@
                 <a:solidFill>
                   <a:srgbClr val="FFFFFF"/>
                 </a:solidFill>
+                <a:latin typeface="Helvetica"/>
               </a:rPr>
-              <a:t>The ask</a:t>
+              <a:t>What comes next for this exemplar</a:t>
             </a:r>
           </a:p>
         </p:txBody>
@@ -9488,8 +9969,8 @@
         </p:nvSpPr>
         <p:spPr>
           <a:xfrm>
-            <a:off x="502920" y="1097280"/>
-            <a:ext cx="8138160" cy="2112264"/>
+            <a:off x="502920" y="1070305"/>
+            <a:ext cx="8138160" cy="2021966"/>
           </a:xfrm>
           <a:prstGeom prst="rect">
             <a:avLst/>
@@ -9497,53 +9978,81 @@
           <a:noFill/>
         </p:spPr>
         <p:txBody>
-          <a:bodyPr wrap="square">
-            <a:spAutoFit/>
+          <a:bodyPr wrap="none" anchor="t" lIns="0" rIns="0" tIns="0" bIns="0">
+            <a:noAutofit/>
           </a:bodyPr>
           <a:lstStyle/>
           <a:p>
             <a:pPr>
+              <a:lnSpc>
+                <a:spcPts val="2100"/>
+              </a:lnSpc>
               <a:spcAft>
-                <a:spcPts val="1000"/>
+                <a:spcPts val="828"/>
               </a:spcAft>
               <a:defRPr sz="1800">
                 <a:solidFill>
                   <a:srgbClr val="0A0A0A"/>
                 </a:solidFill>
+                <a:latin typeface="Helvetica"/>
               </a:defRPr>
             </a:pPr>
             <a:r>
-              <a:t>•  Adopt this pattern for your own methods papers: bind every reported number to the code that produced it, not to a hand-typed table.</a:t>
+              <a:t>• Extend token-sourced facts beyond one pitch subject to any exemplar in the</a:t>
+            </a:r>
+            <a:br/>
+            <a:r>
+              <a:t>roster, so a new deck for a different project needs only new content YAML, not</a:t>
+            </a:r>
+            <a:br/>
+            <a:r>
+              <a:t>new code.</a:t>
             </a:r>
           </a:p>
           <a:p>
             <a:pPr>
+              <a:lnSpc>
+                <a:spcPts val="2100"/>
+              </a:lnSpc>
               <a:spcAft>
-                <a:spcPts val="1000"/>
+                <a:spcPts val="828"/>
               </a:spcAft>
               <a:defRPr sz="1800">
                 <a:solidFill>
                   <a:srgbClr val="0A0A0A"/>
                 </a:solidFill>
+                <a:latin typeface="Helvetica"/>
               </a:defRPr>
             </a:pPr>
             <a:r>
-              <a:t>•  Pilot it on one existing manuscript in your group before committing to a full rewrite.</a:t>
+              <a:t>• Add a second validated pitch (a broader meta-science-group deck) reusing the</a:t>
+            </a:r>
+            <a:br/>
+            <a:r>
+              <a:t>same rendering and audit pipeline.</a:t>
             </a:r>
           </a:p>
           <a:p>
             <a:pPr>
+              <a:lnSpc>
+                <a:spcPts val="2100"/>
+              </a:lnSpc>
               <a:spcAft>
-                <a:spcPts val="1000"/>
+                <a:spcPts val="0"/>
               </a:spcAft>
               <a:defRPr sz="1800">
                 <a:solidFill>
                   <a:srgbClr val="0A0A0A"/>
                 </a:solidFill>
+                <a:latin typeface="Helvetica"/>
               </a:defRPr>
             </a:pPr>
             <a:r>
-              <a:t>•  Happy to pair with your team through a first regeneration cycle and help define your own introspection surface, if useful — no prior engagements to point to yet, this pattern is newly forkable.</a:t>
+              <a:t>• Track deck-generation coverage and drift in the same CI gates that already</a:t>
+            </a:r>
+            <a:br/>
+            <a:r>
+              <a:t>watch every other public exemplar.</a:t>
             </a:r>
           </a:p>
         </p:txBody>
@@ -9673,7 +10182,9 @@
           </a:fontRef>
         </p:style>
         <p:txBody>
-          <a:bodyPr rtlCol="0" anchor="ctr" lIns="502920"/>
+          <a:bodyPr rtlCol="0" anchor="ctr" wrap="none" lIns="502920" rIns="502920">
+            <a:noAutofit/>
+          </a:bodyPr>
           <a:lstStyle/>
           <a:p>
             <a:pPr algn="ctr"/>
@@ -9682,8 +10193,9 @@
                 <a:solidFill>
                   <a:srgbClr val="FFFFFF"/>
                 </a:solidFill>
+                <a:latin typeface="Helvetica"/>
               </a:rPr>
-              <a:t>Funding &amp; consulting</a:t>
+              <a:t>The ask</a:t>
             </a:r>
           </a:p>
         </p:txBody>
@@ -9696,8 +10208,8 @@
         </p:nvSpPr>
         <p:spPr>
           <a:xfrm>
-            <a:off x="502920" y="1097280"/>
-            <a:ext cx="8138160" cy="2560320"/>
+            <a:off x="502920" y="1070305"/>
+            <a:ext cx="8138160" cy="2021967"/>
           </a:xfrm>
           <a:prstGeom prst="rect">
             <a:avLst/>
@@ -9705,53 +10217,81 @@
           <a:noFill/>
         </p:spPr>
         <p:txBody>
-          <a:bodyPr wrap="square">
-            <a:spAutoFit/>
+          <a:bodyPr wrap="none" anchor="t" lIns="0" rIns="0" tIns="0" bIns="0">
+            <a:noAutofit/>
           </a:bodyPr>
           <a:lstStyle/>
           <a:p>
             <a:pPr>
+              <a:lnSpc>
+                <a:spcPts val="2100"/>
+              </a:lnSpc>
               <a:spcAft>
-                <a:spcPts val="1000"/>
+                <a:spcPts val="828"/>
               </a:spcAft>
               <a:defRPr sz="1800">
                 <a:solidFill>
                   <a:srgbClr val="0A0A0A"/>
                 </a:solidFill>
+                <a:latin typeface="Helvetica"/>
               </a:defRPr>
             </a:pPr>
             <a:r>
-              <a:t>•  The code itself is available to adopt directly today — real, tested, and licensed for reuse, no engagement required to start.</a:t>
+              <a:t>• Adopt this pattern for your own methods papers: bind every reported number</a:t>
+            </a:r>
+            <a:br/>
+            <a:r>
+              <a:t>to the code that produced it, not to a hand-typed table.</a:t>
             </a:r>
           </a:p>
           <a:p>
             <a:pPr>
+              <a:lnSpc>
+                <a:spcPts val="2100"/>
+              </a:lnSpc>
               <a:spcAft>
-                <a:spcPts val="1000"/>
+                <a:spcPts val="828"/>
               </a:spcAft>
               <a:defRPr sz="1800">
                 <a:solidFill>
                   <a:srgbClr val="0A0A0A"/>
                 </a:solidFill>
+                <a:latin typeface="Helvetica"/>
               </a:defRPr>
             </a:pPr>
             <a:r>
-              <a:t>•  Open to funding conversations for a dedicated integration (a new pitch subject, a distinct theme, a deeper introspection surface) — no such engagement exists yet, this is an invitation to scope one, not an established program.</a:t>
+              <a:t>• Pilot it on one existing manuscript in your group before committing to a full</a:t>
+            </a:r>
+            <a:br/>
+            <a:r>
+              <a:t>rewrite.</a:t>
             </a:r>
           </a:p>
           <a:p>
             <a:pPr>
+              <a:lnSpc>
+                <a:spcPts val="2100"/>
+              </a:lnSpc>
               <a:spcAft>
-                <a:spcPts val="1000"/>
+                <a:spcPts val="0"/>
               </a:spcAft>
               <a:defRPr sz="1800">
                 <a:solidFill>
                   <a:srgbClr val="0A0A0A"/>
                 </a:solidFill>
+                <a:latin typeface="Helvetica"/>
               </a:defRPr>
             </a:pPr>
             <a:r>
-              <a:t>•  Open to scoping a consulting engagement on request — pairing through a first regeneration cycle, or adapting the two-layer architecture to an existing codebase outside this monorepo. No such engagement has happened yet; this is an invitation, not a track record.</a:t>
+              <a:t>• Happy to pair with your team through a first regeneration cycle and help define</a:t>
+            </a:r>
+            <a:br/>
+            <a:r>
+              <a:t>your own introspection surface, if useful — no prior engagements to point to yet,</a:t>
+            </a:r>
+            <a:br/>
+            <a:r>
+              <a:t>this pattern is newly forkable.</a:t>
             </a:r>
           </a:p>
         </p:txBody>
@@ -9815,6 +10355,253 @@
             <a:avLst/>
           </a:prstGeom>
           <a:solidFill>
+            <a:srgbClr val="FFFFFF"/>
+          </a:solidFill>
+          <a:ln>
+            <a:noFill/>
+          </a:ln>
+          <a:effectLst/>
+        </p:spPr>
+        <p:style>
+          <a:lnRef idx="1">
+            <a:schemeClr val="accent1"/>
+          </a:lnRef>
+          <a:fillRef idx="3">
+            <a:schemeClr val="accent1"/>
+          </a:fillRef>
+          <a:effectRef idx="2">
+            <a:schemeClr val="accent1"/>
+          </a:effectRef>
+          <a:fontRef idx="minor">
+            <a:schemeClr val="lt1"/>
+          </a:fontRef>
+        </p:style>
+        <p:txBody>
+          <a:bodyPr rtlCol="0" anchor="ctr"/>
+          <a:lstStyle/>
+          <a:p>
+            <a:pPr algn="ctr"/>
+          </a:p>
+        </p:txBody>
+      </p:sp>
+      <p:sp>
+        <p:nvSpPr>
+          <p:cNvPr id="3" name="Rectangle 2"/>
+          <p:cNvSpPr/>
+          <p:nvPr/>
+        </p:nvSpPr>
+        <p:spPr>
+          <a:xfrm>
+            <a:off x="0" y="0"/>
+            <a:ext cx="9144000" cy="822960"/>
+          </a:xfrm>
+          <a:prstGeom prst="rect">
+            <a:avLst/>
+          </a:prstGeom>
+          <a:solidFill>
+            <a:srgbClr val="0A0A0A"/>
+          </a:solidFill>
+          <a:ln>
+            <a:noFill/>
+          </a:ln>
+          <a:effectLst/>
+        </p:spPr>
+        <p:style>
+          <a:lnRef idx="1">
+            <a:schemeClr val="accent1"/>
+          </a:lnRef>
+          <a:fillRef idx="3">
+            <a:schemeClr val="accent1"/>
+          </a:fillRef>
+          <a:effectRef idx="2">
+            <a:schemeClr val="accent1"/>
+          </a:effectRef>
+          <a:fontRef idx="minor">
+            <a:schemeClr val="lt1"/>
+          </a:fontRef>
+        </p:style>
+        <p:txBody>
+          <a:bodyPr rtlCol="0" anchor="ctr" wrap="none" lIns="502920" rIns="502920">
+            <a:noAutofit/>
+          </a:bodyPr>
+          <a:lstStyle/>
+          <a:p>
+            <a:pPr algn="ctr"/>
+            <a:r>
+              <a:rPr sz="2400" b="1">
+                <a:solidFill>
+                  <a:srgbClr val="FFFFFF"/>
+                </a:solidFill>
+                <a:latin typeface="Helvetica"/>
+              </a:rPr>
+              <a:t>Funding &amp; consulting</a:t>
+            </a:r>
+          </a:p>
+        </p:txBody>
+      </p:sp>
+      <p:sp>
+        <p:nvSpPr>
+          <p:cNvPr id="4" name="TextBox 3"/>
+          <p:cNvSpPr txBox="1"/>
+          <p:nvPr/>
+        </p:nvSpPr>
+        <p:spPr>
+          <a:xfrm>
+            <a:off x="502920" y="1070305"/>
+            <a:ext cx="8138160" cy="2555366"/>
+          </a:xfrm>
+          <a:prstGeom prst="rect">
+            <a:avLst/>
+          </a:prstGeom>
+          <a:noFill/>
+        </p:spPr>
+        <p:txBody>
+          <a:bodyPr wrap="none" anchor="t" lIns="0" rIns="0" tIns="0" bIns="0">
+            <a:noAutofit/>
+          </a:bodyPr>
+          <a:lstStyle/>
+          <a:p>
+            <a:pPr>
+              <a:lnSpc>
+                <a:spcPts val="2100"/>
+              </a:lnSpc>
+              <a:spcAft>
+                <a:spcPts val="828"/>
+              </a:spcAft>
+              <a:defRPr sz="1800">
+                <a:solidFill>
+                  <a:srgbClr val="0A0A0A"/>
+                </a:solidFill>
+                <a:latin typeface="Helvetica"/>
+              </a:defRPr>
+            </a:pPr>
+            <a:r>
+              <a:t>• The code itself is available to adopt directly today — real, tested, and licensed</a:t>
+            </a:r>
+            <a:br/>
+            <a:r>
+              <a:t>for reuse, no engagement required to start.</a:t>
+            </a:r>
+          </a:p>
+          <a:p>
+            <a:pPr>
+              <a:lnSpc>
+                <a:spcPts val="2100"/>
+              </a:lnSpc>
+              <a:spcAft>
+                <a:spcPts val="828"/>
+              </a:spcAft>
+              <a:defRPr sz="1800">
+                <a:solidFill>
+                  <a:srgbClr val="0A0A0A"/>
+                </a:solidFill>
+                <a:latin typeface="Helvetica"/>
+              </a:defRPr>
+            </a:pPr>
+            <a:r>
+              <a:t>• Open to funding conversations for a dedicated integration (a new pitch subject,</a:t>
+            </a:r>
+            <a:br/>
+            <a:r>
+              <a:t>a distinct theme, a deeper introspection surface) — no such engagement exists</a:t>
+            </a:r>
+            <a:br/>
+            <a:r>
+              <a:t>yet, this is an invitation to scope one, not an established program.</a:t>
+            </a:r>
+          </a:p>
+          <a:p>
+            <a:pPr>
+              <a:lnSpc>
+                <a:spcPts val="2100"/>
+              </a:lnSpc>
+              <a:spcAft>
+                <a:spcPts val="0"/>
+              </a:spcAft>
+              <a:defRPr sz="1800">
+                <a:solidFill>
+                  <a:srgbClr val="0A0A0A"/>
+                </a:solidFill>
+                <a:latin typeface="Helvetica"/>
+              </a:defRPr>
+            </a:pPr>
+            <a:r>
+              <a:t>• Open to scoping a consulting engagement on request — pairing through a first</a:t>
+            </a:r>
+            <a:br/>
+            <a:r>
+              <a:t>regeneration cycle, or adapting the two-layer architecture to an existing</a:t>
+            </a:r>
+            <a:br/>
+            <a:r>
+              <a:t>codebase outside this monorepo. No such engagement has happened yet; this</a:t>
+            </a:r>
+            <a:br/>
+            <a:r>
+              <a:t>is an invitation, not a track record.</a:t>
+            </a:r>
+          </a:p>
+        </p:txBody>
+      </p:sp>
+      <p:pic>
+        <p:nvPicPr>
+          <p:cNvPr id="5" name="Picture 4" descr="image.png">
+            <a:hlinkClick r:id="rId3"/>
+          </p:cNvPr>
+          <p:cNvPicPr>
+            <a:picLocks noChangeAspect="1"/>
+          </p:cNvPicPr>
+          <p:nvPr/>
+        </p:nvPicPr>
+        <p:blipFill>
+          <a:blip r:embed="rId2"/>
+          <a:stretch>
+            <a:fillRect/>
+          </a:stretch>
+        </p:blipFill>
+        <p:spPr>
+          <a:xfrm>
+            <a:off x="8074152" y="4466844"/>
+            <a:ext cx="566928" cy="566928"/>
+          </a:xfrm>
+          <a:prstGeom prst="rect">
+            <a:avLst/>
+          </a:prstGeom>
+        </p:spPr>
+      </p:pic>
+    </p:spTree>
+  </p:cSld>
+  <p:clrMapOvr>
+    <a:masterClrMapping/>
+  </p:clrMapOvr>
+</p:sld>
+</file>
+
+<file path=ppt/slides/slide38.xml><?xml version="1.0" encoding="utf-8"?>
+<p:sld xmlns:a="http://schemas.openxmlformats.org/drawingml/2006/main" xmlns:p="http://schemas.openxmlformats.org/presentationml/2006/main" xmlns:r="http://schemas.openxmlformats.org/officeDocument/2006/relationships">
+  <p:cSld>
+    <p:spTree>
+      <p:nvGrpSpPr>
+        <p:cNvPr id="1" name=""/>
+        <p:cNvGrpSpPr/>
+        <p:nvPr/>
+      </p:nvGrpSpPr>
+      <p:grpSpPr/>
+      <p:sp>
+        <p:nvSpPr>
+          <p:cNvPr id="2" name="Rectangle 1"/>
+          <p:cNvSpPr/>
+          <p:nvPr/>
+        </p:nvSpPr>
+        <p:spPr>
+          <a:xfrm>
+            <a:off x="0" y="0"/>
+            <a:ext cx="9144000" cy="5143500"/>
+          </a:xfrm>
+          <a:prstGeom prst="rect">
+            <a:avLst/>
+          </a:prstGeom>
+          <a:solidFill>
             <a:srgbClr val="0A0A0A"/>
           </a:solidFill>
           <a:ln>
@@ -10079,7 +10866,9 @@
           </a:fontRef>
         </p:style>
         <p:txBody>
-          <a:bodyPr rtlCol="0" anchor="ctr" lIns="502920"/>
+          <a:bodyPr rtlCol="0" anchor="ctr" wrap="none" lIns="502920" rIns="502920">
+            <a:noAutofit/>
+          </a:bodyPr>
           <a:lstStyle/>
           <a:p>
             <a:pPr algn="ctr"/>
@@ -10088,6 +10877,7 @@
                 <a:solidFill>
                   <a:srgbClr val="FFFFFF"/>
                 </a:solidFill>
+                <a:latin typeface="Helvetica"/>
               </a:rPr>
               <a:t>Where meta-science tooling stands today</a:t>
             </a:r>
@@ -10102,8 +10892,8 @@
         </p:nvSpPr>
         <p:spPr>
           <a:xfrm>
-            <a:off x="502920" y="1097280"/>
-            <a:ext cx="8138160" cy="2368296"/>
+            <a:off x="502920" y="1070305"/>
+            <a:ext cx="8138160" cy="1755267"/>
           </a:xfrm>
           <a:prstGeom prst="rect">
             <a:avLst/>
@@ -10111,53 +10901,77 @@
           <a:noFill/>
         </p:spPr>
         <p:txBody>
-          <a:bodyPr wrap="square">
-            <a:spAutoFit/>
+          <a:bodyPr wrap="none" anchor="t" lIns="0" rIns="0" tIns="0" bIns="0">
+            <a:noAutofit/>
           </a:bodyPr>
           <a:lstStyle/>
           <a:p>
             <a:pPr>
+              <a:lnSpc>
+                <a:spcPts val="2100"/>
+              </a:lnSpc>
               <a:spcAft>
-                <a:spcPts val="1000"/>
+                <a:spcPts val="828"/>
               </a:spcAft>
               <a:defRPr sz="1800">
                 <a:solidFill>
                   <a:srgbClr val="0A0A0A"/>
                 </a:solidFill>
+                <a:latin typeface="Helvetica"/>
               </a:defRPr>
             </a:pPr>
             <a:r>
-              <a:t>•  Electronic lab notebooks and preregistration platforms address the experiment layer, not the infrastructure-description layer.</a:t>
+              <a:t>• Electronic lab notebooks and preregistration platforms address the experiment</a:t>
+            </a:r>
+            <a:br/>
+            <a:r>
+              <a:t>layer, not the infrastructure-description layer.</a:t>
             </a:r>
           </a:p>
           <a:p>
             <a:pPr>
+              <a:lnSpc>
+                <a:spcPts val="2100"/>
+              </a:lnSpc>
               <a:spcAft>
-                <a:spcPts val="1000"/>
+                <a:spcPts val="828"/>
               </a:spcAft>
               <a:defRPr sz="1800">
                 <a:solidFill>
                   <a:srgbClr val="0A0A0A"/>
                 </a:solidFill>
+                <a:latin typeface="Helvetica"/>
               </a:defRPr>
             </a:pPr>
             <a:r>
-              <a:t>•  Literate-programming tools (R Markdown, Jupyter, Quarto) bind prose to code within one document, but rarely to a whole repository's live state.</a:t>
+              <a:t>• Literate-programming tools (R Markdown, Jupyter, Quarto) bind prose to code</a:t>
+            </a:r>
+            <a:br/>
+            <a:r>
+              <a:t>within one document, but rarely to a whole repository's live state.</a:t>
             </a:r>
           </a:p>
           <a:p>
             <a:pPr>
+              <a:lnSpc>
+                <a:spcPts val="2100"/>
+              </a:lnSpc>
               <a:spcAft>
-                <a:spcPts val="1000"/>
+                <a:spcPts val="0"/>
               </a:spcAft>
               <a:defRPr sz="1800">
                 <a:solidFill>
                   <a:srgbClr val="0A0A0A"/>
                 </a:solidFill>
+                <a:latin typeface="Helvetica"/>
               </a:defRPr>
             </a:pPr>
             <a:r>
-              <a:t>•  Very few public examples exist of a manuscript that introspects and reports on the software system that produced it, at repository scale.</a:t>
+              <a:t>• Very few public examples exist of a manuscript that introspects and reports on</a:t>
+            </a:r>
+            <a:br/>
+            <a:r>
+              <a:t>the software system that produced it, at repository scale.</a:t>
             </a:r>
           </a:p>
         </p:txBody>
@@ -10287,7 +11101,9 @@
           </a:fontRef>
         </p:style>
         <p:txBody>
-          <a:bodyPr rtlCol="0" anchor="ctr" lIns="502920"/>
+          <a:bodyPr rtlCol="0" anchor="ctr" wrap="none" lIns="502920" rIns="502920">
+            <a:noAutofit/>
+          </a:bodyPr>
           <a:lstStyle/>
           <a:p>
             <a:pPr algn="ctr"/>
@@ -10296,6 +11112,7 @@
                 <a:solidFill>
                   <a:srgbClr val="FFFFFF"/>
                 </a:solidFill>
+                <a:latin typeface="Helvetica"/>
               </a:rPr>
               <a:t>What template_template is</a:t>
             </a:r>
@@ -10310,8 +11127,8 @@
         </p:nvSpPr>
         <p:spPr>
           <a:xfrm>
-            <a:off x="502920" y="1097280"/>
-            <a:ext cx="8138160" cy="2112264"/>
+            <a:off x="502920" y="1070305"/>
+            <a:ext cx="8138160" cy="1755267"/>
           </a:xfrm>
           <a:prstGeom prst="rect">
             <a:avLst/>
@@ -10319,53 +11136,77 @@
           <a:noFill/>
         </p:spPr>
         <p:txBody>
-          <a:bodyPr wrap="square">
-            <a:spAutoFit/>
+          <a:bodyPr wrap="none" anchor="t" lIns="0" rIns="0" tIns="0" bIns="0">
+            <a:noAutofit/>
           </a:bodyPr>
           <a:lstStyle/>
           <a:p>
             <a:pPr>
+              <a:lnSpc>
+                <a:spcPts val="2100"/>
+              </a:lnSpc>
               <a:spcAft>
-                <a:spcPts val="1000"/>
+                <a:spcPts val="828"/>
               </a:spcAft>
               <a:defRPr sz="1800">
                 <a:solidFill>
                   <a:srgbClr val="0A0A0A"/>
                 </a:solidFill>
+                <a:latin typeface="Helvetica"/>
               </a:defRPr>
             </a:pPr>
             <a:r>
-              <a:t>•  A manuscript that is generated FROM the repository it describes, not written ABOUT it from memory.</a:t>
+              <a:t>• A manuscript that is generated FROM the repository it describes, not written</a:t>
+            </a:r>
+            <a:br/>
+            <a:r>
+              <a:t>ABOUT it from memory.</a:t>
             </a:r>
           </a:p>
           <a:p>
             <a:pPr>
+              <a:lnSpc>
+                <a:spcPts val="2100"/>
+              </a:lnSpc>
               <a:spcAft>
-                <a:spcPts val="1000"/>
+                <a:spcPts val="828"/>
               </a:spcAft>
               <a:defRPr sz="1800">
                 <a:solidFill>
                   <a:srgbClr val="0A0A0A"/>
                 </a:solidFill>
+                <a:latin typeface="Helvetica"/>
               </a:defRPr>
             </a:pPr>
             <a:r>
-              <a:t>•  Every metric in the paper — module counts, test counts, pipeline stages — is computed live by template_template's own introspection code.</a:t>
+              <a:t>• Every metric in the paper — module counts, test counts, pipeline stages — is</a:t>
+            </a:r>
+            <a:br/>
+            <a:r>
+              <a:t>computed live by template_template's own introspection code.</a:t>
             </a:r>
           </a:p>
           <a:p>
             <a:pPr>
+              <a:lnSpc>
+                <a:spcPts val="2100"/>
+              </a:lnSpc>
               <a:spcAft>
-                <a:spcPts val="1000"/>
+                <a:spcPts val="0"/>
               </a:spcAft>
               <a:defRPr sz="1800">
                 <a:solidFill>
                   <a:srgbClr val="0A0A0A"/>
                 </a:solidFill>
+                <a:latin typeface="Helvetica"/>
               </a:defRPr>
             </a:pPr>
             <a:r>
-              <a:t>•  One of 24 public exemplar templates in the same monorepo, each independently tested and coverage-gated.</a:t>
+              <a:t>• One of 24 public exemplar templates in the same monorepo, each</a:t>
+            </a:r>
+            <a:br/>
+            <a:r>
+              <a:t>independently tested and coverage-gated.</a:t>
             </a:r>
           </a:p>
         </p:txBody>
@@ -10732,7 +11573,7 @@
         </p:nvSpPr>
         <p:spPr>
           <a:xfrm>
-            <a:off x="502920" y="2514600"/>
+            <a:off x="502920" y="2559050"/>
             <a:ext cx="8138160" cy="38100"/>
           </a:xfrm>
           <a:prstGeom prst="rect">
@@ -10776,8 +11617,8 @@
         </p:nvSpPr>
         <p:spPr>
           <a:xfrm>
-            <a:off x="502920" y="2103120"/>
-            <a:ext cx="8138160" cy="914400"/>
+            <a:off x="502920" y="1918970"/>
+            <a:ext cx="8138160" cy="502920"/>
           </a:xfrm>
           <a:prstGeom prst="rect">
             <a:avLst/>
@@ -10785,16 +11626,22 @@
           <a:noFill/>
         </p:spPr>
         <p:txBody>
-          <a:bodyPr wrap="square">
-            <a:spAutoFit/>
+          <a:bodyPr wrap="none" anchor="t" lIns="0" rIns="0" tIns="0" bIns="0">
+            <a:noAutofit/>
           </a:bodyPr>
           <a:lstStyle/>
           <a:p>
+            <a:pPr>
+              <a:lnSpc>
+                <a:spcPts val="3300"/>
+              </a:lnSpc>
+            </a:pPr>
             <a:r>
               <a:rPr sz="3300" b="1">
                 <a:solidFill>
                   <a:srgbClr val="0A0A0A"/>
                 </a:solidFill>
+                <a:latin typeface="Helvetica"/>
               </a:rPr>
               <a:t>How it works</a:t>
             </a:r>
@@ -10926,7 +11773,9 @@
           </a:fontRef>
         </p:style>
         <p:txBody>
-          <a:bodyPr rtlCol="0" anchor="ctr" lIns="502920"/>
+          <a:bodyPr rtlCol="0" anchor="ctr" wrap="none" lIns="502920" rIns="502920">
+            <a:noAutofit/>
+          </a:bodyPr>
           <a:lstStyle/>
           <a:p>
             <a:pPr algn="ctr"/>
@@ -10935,6 +11784,7 @@
                 <a:solidFill>
                   <a:srgbClr val="FFFFFF"/>
                 </a:solidFill>
+                <a:latin typeface="Helvetica"/>
               </a:rPr>
               <a:t>Introspection</a:t>
             </a:r>
@@ -10949,8 +11799,8 @@
         </p:nvSpPr>
         <p:spPr>
           <a:xfrm>
-            <a:off x="502920" y="1097280"/>
-            <a:ext cx="8138160" cy="2368296"/>
+            <a:off x="502920" y="1070305"/>
+            <a:ext cx="8138160" cy="2021967"/>
           </a:xfrm>
           <a:prstGeom prst="rect">
             <a:avLst/>
@@ -10958,53 +11808,81 @@
           <a:noFill/>
         </p:spPr>
         <p:txBody>
-          <a:bodyPr wrap="square">
-            <a:spAutoFit/>
+          <a:bodyPr wrap="none" anchor="t" lIns="0" rIns="0" tIns="0" bIns="0">
+            <a:noAutofit/>
           </a:bodyPr>
           <a:lstStyle/>
           <a:p>
             <a:pPr>
+              <a:lnSpc>
+                <a:spcPts val="2100"/>
+              </a:lnSpc>
               <a:spcAft>
-                <a:spcPts val="1000"/>
+                <a:spcPts val="828"/>
               </a:spcAft>
               <a:defRPr sz="1800">
                 <a:solidFill>
                   <a:srgbClr val="0A0A0A"/>
                 </a:solidFill>
+                <a:latin typeface="Helvetica"/>
               </a:defRPr>
             </a:pPr>
             <a:r>
-              <a:t>•  src/template_template/introspection.py discovers infrastructure/ subpackages, the pipeline.yaml stage DAG, and the public exemplar roster.</a:t>
+              <a:t>• src/template_template/introspection.py discovers infrastructure/ subpackages,</a:t>
+            </a:r>
+            <a:br/>
+            <a:r>
+              <a:t>the pipeline.yaml stage DAG, and the public exemplar roster.</a:t>
             </a:r>
           </a:p>
           <a:p>
             <a:pPr>
+              <a:lnSpc>
+                <a:spcPts val="2100"/>
+              </a:lnSpc>
               <a:spcAft>
-                <a:spcPts val="1000"/>
+                <a:spcPts val="828"/>
               </a:spcAft>
               <a:defRPr sz="1800">
                 <a:solidFill>
                   <a:srgbClr val="0A0A0A"/>
                 </a:solidFill>
+                <a:latin typeface="Helvetica"/>
               </a:defRPr>
             </a:pPr>
             <a:r>
-              <a:t>•  The scan reads the filesystem and YAML directly — it does not depend on any external service or cached snapshot.</a:t>
+              <a:t>• The scan reads the filesystem and YAML directly — it does not depend on any</a:t>
+            </a:r>
+            <a:br/>
+            <a:r>
+              <a:t>external service or cached snapshot.</a:t>
             </a:r>
           </a:p>
           <a:p>
             <a:pPr>
+              <a:lnSpc>
+                <a:spcPts val="2100"/>
+              </a:lnSpc>
               <a:spcAft>
-                <a:spcPts val="1000"/>
+                <a:spcPts val="0"/>
               </a:spcAft>
               <a:defRPr sz="1800">
                 <a:solidFill>
                   <a:srgbClr val="0A0A0A"/>
                 </a:solidFill>
+                <a:latin typeface="Helvetica"/>
               </a:defRPr>
             </a:pPr>
             <a:r>
-              <a:t>•  Function-level entry points (discover_infrastructure_modules, discover_projects, load_pipeline_stages_from_yaml) each return typed, testable dataclasses.</a:t>
+              <a:t>• Function-level entry points (discover_infrastructure_modules,</a:t>
+            </a:r>
+            <a:br/>
+            <a:r>
+              <a:t>discover_projects, load_pipeline_stages_from_yaml) each return typed, testable</a:t>
+            </a:r>
+            <a:br/>
+            <a:r>
+              <a:t>dataclasses.</a:t>
             </a:r>
           </a:p>
         </p:txBody>
@@ -11134,7 +12012,9 @@
           </a:fontRef>
         </p:style>
         <p:txBody>
-          <a:bodyPr rtlCol="0" anchor="ctr" lIns="502920"/>
+          <a:bodyPr rtlCol="0" anchor="ctr" wrap="none" lIns="502920" rIns="502920">
+            <a:noAutofit/>
+          </a:bodyPr>
           <a:lstStyle/>
           <a:p>
             <a:pPr algn="ctr"/>
@@ -11143,6 +12023,7 @@
                 <a:solidFill>
                   <a:srgbClr val="FFFFFF"/>
                 </a:solidFill>
+                <a:latin typeface="Helvetica"/>
               </a:rPr>
               <a:t>Metrics and injection</a:t>
             </a:r>
@@ -11157,8 +12038,8 @@
         </p:nvSpPr>
         <p:spPr>
           <a:xfrm>
-            <a:off x="502920" y="1097280"/>
-            <a:ext cx="8138160" cy="2112264"/>
+            <a:off x="502920" y="1070305"/>
+            <a:ext cx="8138160" cy="1755267"/>
           </a:xfrm>
           <a:prstGeom prst="rect">
             <a:avLst/>
@@ -11166,53 +12047,77 @@
           <a:noFill/>
         </p:spPr>
         <p:txBody>
-          <a:bodyPr wrap="square">
-            <a:spAutoFit/>
+          <a:bodyPr wrap="none" anchor="t" lIns="0" rIns="0" tIns="0" bIns="0">
+            <a:noAutofit/>
           </a:bodyPr>
           <a:lstStyle/>
           <a:p>
             <a:pPr>
+              <a:lnSpc>
+                <a:spcPts val="2100"/>
+              </a:lnSpc>
               <a:spcAft>
-                <a:spcPts val="1000"/>
+                <a:spcPts val="828"/>
               </a:spcAft>
               <a:defRPr sz="1800">
                 <a:solidFill>
                   <a:srgbClr val="0A0A0A"/>
                 </a:solidFill>
+                <a:latin typeface="Helvetica"/>
               </a:defRPr>
             </a:pPr>
             <a:r>
-              <a:t>•  metrics.py turns the introspection scan into a dictionary of ${variable} values — the same token convention used across every exemplar's manuscript.</a:t>
+              <a:t>• metrics.py turns the introspection scan into a dictionary of ${variable} values —</a:t>
+            </a:r>
+            <a:br/>
+            <a:r>
+              <a:t>the same token convention used across every exemplar's manuscript.</a:t>
             </a:r>
           </a:p>
           <a:p>
             <a:pPr>
+              <a:lnSpc>
+                <a:spcPts val="2100"/>
+              </a:lnSpc>
               <a:spcAft>
-                <a:spcPts val="1000"/>
+                <a:spcPts val="828"/>
               </a:spcAft>
               <a:defRPr sz="1800">
                 <a:solidFill>
                   <a:srgbClr val="0A0A0A"/>
                 </a:solidFill>
+                <a:latin typeface="Helvetica"/>
               </a:defRPr>
             </a:pPr>
             <a:r>
-              <a:t>•  inject_metrics.py substitutes those values into manuscript/*.md, writing the resolved text to output/manuscript/ for rendering.</a:t>
+              <a:t>• inject_metrics.py substitutes those values into manuscript/*.md, writing the</a:t>
+            </a:r>
+            <a:br/>
+            <a:r>
+              <a:t>resolved text to output/manuscript/ for rendering.</a:t>
             </a:r>
           </a:p>
           <a:p>
             <a:pPr>
+              <a:lnSpc>
+                <a:spcPts val="2100"/>
+              </a:lnSpc>
               <a:spcAft>
-                <a:spcPts val="1000"/>
+                <a:spcPts val="0"/>
               </a:spcAft>
               <a:defRPr sz="1800">
                 <a:solidFill>
                   <a:srgbClr val="0A0A0A"/>
                 </a:solidFill>
+                <a:latin typeface="Helvetica"/>
               </a:defRPr>
             </a:pPr>
             <a:r>
-              <a:t>•  Re-running the pipeline regenerates the paper from current repository state — the citation and the artifact cannot drift apart.</a:t>
+              <a:t>• Re-running the pipeline regenerates the paper from current repository state —</a:t>
+            </a:r>
+            <a:br/>
+            <a:r>
+              <a:t>the citation and the artifact cannot drift apart.</a:t>
             </a:r>
           </a:p>
         </p:txBody>

</xml_diff>